<commit_message>
skh-pt: 10-page deck (no cover/closing) and paragraph-level text boxes in PPTX
Multi-line paragraphs in the same HTML block now become one text box with
line breaks and exact line spacing (vertical offset calibrated), so text is
edited per paragraph instead of per line.

Co-Authored-By: Claude Opus 5.5 <noreply@anthropic.com>
Claude-Session: https://claude.ai/code/session_01D2YY6No1o1YF3BX8eJSF6k
</commit_message>
<xml_diff>
--- a/skh-pt/pptx/deck5.pptx
+++ b/skh-pt/pptx/deck5.pptx
@@ -4630,14 +4630,14 @@
       </p:sp>
       <p:sp>
         <p:nvSpPr>
-          <p:cNvPr id="87" name="BIM 전면 도입이 추진되지만, BIM은 여전히"/>
+          <p:cNvPr id="87" name="BIM 전면 도입이 추진되지만, BIM은 여전히사람이 2D 도면을 보고 "/>
           <p:cNvSpPr txBox="1"/>
           <p:nvPr/>
         </p:nvSpPr>
         <p:spPr>
           <a:xfrm>
-            <a:off x="609600" y="666750"/>
-            <a:ext cx="4968845" cy="349250"/>
+            <a:off x="609600" y="653852"/>
+            <a:ext cx="5143115" cy="724297"/>
           </a:xfrm>
           <a:prstGeom prst="rect">
             <a:avLst/>
@@ -4646,10 +4646,13 @@
           <a:ln/>
         </p:spPr>
         <p:txBody>
-          <a:bodyPr wrap="none" lIns="0" tIns="0" rIns="0" bIns="0" rtlCol="0" anchor="ctr"/>
-          <a:lstStyle/>
-          <a:p>
-            <a:pPr algn="l" indent="0" marL="0">
+          <a:bodyPr wrap="none" lIns="0" tIns="0" rIns="0" bIns="0" rtlCol="0" anchor="t"/>
+          <a:lstStyle/>
+          <a:p>
+            <a:pPr algn="l" indent="0" marL="0">
+              <a:lnSpc>
+                <a:spcPts val="2852"/>
+              </a:lnSpc>
               <a:buNone/>
             </a:pPr>
             <a:r>
@@ -4665,30 +4668,11 @@
             </a:r>
             <a:endParaRPr lang="en-US" sz="2300" dirty="0"/>
           </a:p>
-        </p:txBody>
-      </p:sp>
-      <p:sp>
-        <p:nvSpPr>
-          <p:cNvPr id="88" name="사람이 2D 도면을 보고 직접 만들고 있습니다."/>
-          <p:cNvSpPr txBox="1"/>
-          <p:nvPr/>
-        </p:nvSpPr>
-        <p:spPr>
-          <a:xfrm>
-            <a:off x="609600" y="1028898"/>
-            <a:ext cx="5143115" cy="349250"/>
-          </a:xfrm>
-          <a:prstGeom prst="rect">
-            <a:avLst/>
-          </a:prstGeom>
-          <a:noFill/>
-          <a:ln/>
-        </p:spPr>
-        <p:txBody>
-          <a:bodyPr wrap="none" lIns="0" tIns="0" rIns="0" bIns="0" rtlCol="0" anchor="ctr"/>
-          <a:lstStyle/>
-          <a:p>
-            <a:pPr algn="l" indent="0" marL="0">
+          <a:p>
+            <a:pPr algn="l" indent="0" marL="0">
+              <a:lnSpc>
+                <a:spcPts val="2852"/>
+              </a:lnSpc>
               <a:buNone/>
             </a:pPr>
             <a:r>
@@ -4703,6 +4687,9 @@
               <a:t>사람이 2D 도면을 보고 직접</a:t>
             </a:r>
             <a:pPr algn="l" indent="0" marL="0">
+              <a:lnSpc>
+                <a:spcPts val="2852"/>
+              </a:lnSpc>
               <a:buNone/>
             </a:pPr>
             <a:r>
@@ -4722,7 +4709,7 @@
       </p:sp>
       <p:sp>
         <p:nvSpPr>
-          <p:cNvPr id="89" name="01"/>
+          <p:cNvPr id="88" name="01"/>
           <p:cNvSpPr txBox="1"/>
           <p:nvPr/>
         </p:nvSpPr>
@@ -4761,7 +4748,7 @@
       </p:sp>
       <p:sp>
         <p:nvSpPr>
-          <p:cNvPr id="90" name="02"/>
+          <p:cNvPr id="89" name="02"/>
           <p:cNvSpPr txBox="1"/>
           <p:nvPr/>
         </p:nvSpPr>
@@ -4800,7 +4787,7 @@
       </p:sp>
       <p:sp>
         <p:nvSpPr>
-          <p:cNvPr id="91" name="03"/>
+          <p:cNvPr id="90" name="03"/>
           <p:cNvSpPr txBox="1"/>
           <p:nvPr/>
         </p:nvSpPr>
@@ -4839,7 +4826,7 @@
       </p:sp>
       <p:sp>
         <p:nvSpPr>
-          <p:cNvPr id="92" name="04"/>
+          <p:cNvPr id="91" name="04"/>
           <p:cNvSpPr txBox="1"/>
           <p:nvPr/>
         </p:nvSpPr>
@@ -4878,7 +4865,7 @@
       </p:sp>
       <p:sp>
         <p:nvSpPr>
-          <p:cNvPr id="93" name="05"/>
+          <p:cNvPr id="92" name="05"/>
           <p:cNvSpPr txBox="1"/>
           <p:nvPr/>
         </p:nvSpPr>
@@ -4917,7 +4904,7 @@
       </p:sp>
       <p:sp>
         <p:nvSpPr>
-          <p:cNvPr id="94" name="정책"/>
+          <p:cNvPr id="93" name="정책"/>
           <p:cNvSpPr txBox="1"/>
           <p:nvPr/>
         </p:nvSpPr>
@@ -4956,7 +4943,7 @@
       </p:sp>
       <p:sp>
         <p:nvSpPr>
-          <p:cNvPr id="95" name="국토교통부, BIM 전면 도입 추진"/>
+          <p:cNvPr id="94" name="국토교통부, BIM 전면 도입 추진"/>
           <p:cNvSpPr txBox="1"/>
           <p:nvPr/>
         </p:nvSpPr>
@@ -4995,7 +4982,7 @@
       </p:sp>
       <p:sp>
         <p:nvSpPr>
-          <p:cNvPr id="96" name="공공공사 BIM 의무화 단계적 확대"/>
+          <p:cNvPr id="95" name="공공공사 BIM 의무화 단계적 확대"/>
           <p:cNvSpPr txBox="1"/>
           <p:nvPr/>
         </p:nvSpPr>
@@ -5034,7 +5021,7 @@
       </p:sp>
       <p:sp>
         <p:nvSpPr>
-          <p:cNvPr id="97" name="'22~'24"/>
+          <p:cNvPr id="96" name="'22~'24"/>
           <p:cNvSpPr txBox="1"/>
           <p:nvPr/>
         </p:nvSpPr>
@@ -5073,7 +5060,7 @@
       </p:sp>
       <p:sp>
         <p:nvSpPr>
-          <p:cNvPr id="98" name="'26"/>
+          <p:cNvPr id="97" name="'26"/>
           <p:cNvSpPr txBox="1"/>
           <p:nvPr/>
         </p:nvSpPr>
@@ -5112,7 +5099,7 @@
       </p:sp>
       <p:sp>
         <p:nvSpPr>
-          <p:cNvPr id="99" name="'28"/>
+          <p:cNvPr id="98" name="'28"/>
           <p:cNvSpPr txBox="1"/>
           <p:nvPr/>
         </p:nvSpPr>
@@ -5151,7 +5138,7 @@
       </p:sp>
       <p:sp>
         <p:nvSpPr>
-          <p:cNvPr id="100" name="1,000억원 이상 신규 사업"/>
+          <p:cNvPr id="99" name="1,000억원 이상 신규 사업"/>
           <p:cNvSpPr txBox="1"/>
           <p:nvPr/>
         </p:nvSpPr>
@@ -5190,7 +5177,7 @@
       </p:sp>
       <p:sp>
         <p:nvSpPr>
-          <p:cNvPr id="101" name="도로 → 철도·건축 → 하천·항만"/>
+          <p:cNvPr id="100" name="도로 → 철도·건축 → 하천·항만"/>
           <p:cNvSpPr txBox="1"/>
           <p:nvPr/>
         </p:nvSpPr>
@@ -5229,7 +5216,7 @@
       </p:sp>
       <p:sp>
         <p:nvSpPr>
-          <p:cNvPr id="102" name="500억원 이상"/>
+          <p:cNvPr id="101" name="500억원 이상"/>
           <p:cNvSpPr txBox="1"/>
           <p:nvPr/>
         </p:nvSpPr>
@@ -5268,7 +5255,7 @@
       </p:sp>
       <p:sp>
         <p:nvSpPr>
-          <p:cNvPr id="103" name="300억원 이상"/>
+          <p:cNvPr id="102" name="300억원 이상"/>
           <p:cNvSpPr txBox="1"/>
           <p:nvPr/>
         </p:nvSpPr>
@@ -5307,7 +5294,7 @@
       </p:sp>
       <p:sp>
         <p:nvSpPr>
-          <p:cNvPr id="104" name="2030 건축BIM 로드맵"/>
+          <p:cNvPr id="103" name="2030 건축BIM 로드맵"/>
           <p:cNvSpPr txBox="1"/>
           <p:nvPr/>
         </p:nvSpPr>
@@ -5346,7 +5333,7 @@
       </p:sp>
       <p:sp>
         <p:nvSpPr>
-          <p:cNvPr id="105" name="'25"/>
+          <p:cNvPr id="104" name="'25"/>
           <p:cNvSpPr txBox="1"/>
           <p:nvPr/>
         </p:nvSpPr>
@@ -5385,7 +5372,7 @@
       </p:sp>
       <p:sp>
         <p:nvSpPr>
-          <p:cNvPr id="106" name="BIM 설계 기반 구축"/>
+          <p:cNvPr id="105" name="BIM 설계 기반 구축"/>
           <p:cNvSpPr txBox="1"/>
           <p:nvPr/>
         </p:nvSpPr>
@@ -5424,7 +5411,7 @@
       </p:sp>
       <p:sp>
         <p:nvSpPr>
-          <p:cNvPr id="107" name="'30"/>
+          <p:cNvPr id="106" name="'30"/>
           <p:cNvSpPr txBox="1"/>
           <p:nvPr/>
         </p:nvSpPr>
@@ -5463,7 +5450,7 @@
       </p:sp>
       <p:sp>
         <p:nvSpPr>
-          <p:cNvPr id="108" name="디지털 건축서비스 완전 구현"/>
+          <p:cNvPr id="107" name="디지털 건축서비스 완전 구현"/>
           <p:cNvSpPr txBox="1"/>
           <p:nvPr/>
         </p:nvSpPr>
@@ -5502,7 +5489,7 @@
       </p:sp>
       <p:sp>
         <p:nvSpPr>
-          <p:cNvPr id="109" name="출처: 국토교통부 「스마트 건설 활성화 방안」, 「2030 건축BIM 로"/>
+          <p:cNvPr id="108" name="출처: 국토교통부 「스마트 건설 활성화 방안」, 「2030 건축BIM 로"/>
           <p:cNvSpPr txBox="1"/>
           <p:nvPr/>
         </p:nvSpPr>
@@ -5541,7 +5528,7 @@
       </p:sp>
       <p:sp>
         <p:nvSpPr>
-          <p:cNvPr id="110" name="현실"/>
+          <p:cNvPr id="109" name="현실"/>
           <p:cNvSpPr txBox="1"/>
           <p:nvPr/>
         </p:nvSpPr>
@@ -5580,7 +5567,7 @@
       </p:sp>
       <p:sp>
         <p:nvSpPr>
-          <p:cNvPr id="111" name="대부분의 BIM은 2D 도면에서 출발"/>
+          <p:cNvPr id="110" name="대부분의 BIM은 2D 도면에서 출발"/>
           <p:cNvSpPr txBox="1"/>
           <p:nvPr/>
         </p:nvSpPr>
@@ -5619,7 +5606,7 @@
       </p:sp>
       <p:sp>
         <p:nvSpPr>
-          <p:cNvPr id="112" name="신규 건설 프로젝트"/>
+          <p:cNvPr id="111" name="신규 건설 프로젝트"/>
           <p:cNvSpPr txBox="1"/>
           <p:nvPr/>
         </p:nvSpPr>
@@ -5658,14 +5645,14 @@
       </p:sp>
       <p:sp>
         <p:nvSpPr>
-          <p:cNvPr id="113" name="2D 도면을 먼저 그린 뒤 BIM으로 옮기는"/>
+          <p:cNvPr id="112" name="2D 도면을 먼저 그린 뒤 BIM으로 옮기는'BIM 전환설계'가 대부분"/>
           <p:cNvSpPr txBox="1"/>
           <p:nvPr/>
         </p:nvSpPr>
         <p:spPr>
           <a:xfrm>
-            <a:off x="4470400" y="2718197"/>
-            <a:ext cx="2239635" cy="165100"/>
+            <a:off x="4470400" y="2673747"/>
+            <a:ext cx="2239635" cy="419100"/>
           </a:xfrm>
           <a:prstGeom prst="rect">
             <a:avLst/>
@@ -5674,10 +5661,13 @@
           <a:ln/>
         </p:spPr>
         <p:txBody>
-          <a:bodyPr wrap="none" lIns="0" tIns="0" rIns="0" bIns="0" rtlCol="0" anchor="ctr"/>
-          <a:lstStyle/>
-          <a:p>
-            <a:pPr algn="l" indent="0" marL="0">
+          <a:bodyPr wrap="none" lIns="0" tIns="0" rIns="0" bIns="0" rtlCol="0" anchor="t"/>
+          <a:lstStyle/>
+          <a:p>
+            <a:pPr algn="l" indent="0" marL="0">
+              <a:lnSpc>
+                <a:spcPts val="1650"/>
+              </a:lnSpc>
               <a:buNone/>
             </a:pPr>
             <a:r>
@@ -5693,30 +5683,11 @@
             </a:r>
             <a:endParaRPr lang="en-US" sz="1100" dirty="0"/>
           </a:p>
-        </p:txBody>
-      </p:sp>
-      <p:sp>
-        <p:nvSpPr>
-          <p:cNvPr id="114" name="'BIM 전환설계'가 대부분"/>
-          <p:cNvSpPr txBox="1"/>
-          <p:nvPr/>
-        </p:nvSpPr>
-        <p:spPr>
-          <a:xfrm>
-            <a:off x="4470400" y="2927747"/>
-            <a:ext cx="1363553" cy="165100"/>
-          </a:xfrm>
-          <a:prstGeom prst="rect">
-            <a:avLst/>
-          </a:prstGeom>
-          <a:noFill/>
-          <a:ln/>
-        </p:spPr>
-        <p:txBody>
-          <a:bodyPr wrap="none" lIns="0" tIns="0" rIns="0" bIns="0" rtlCol="0" anchor="ctr"/>
-          <a:lstStyle/>
-          <a:p>
-            <a:pPr algn="l" indent="0" marL="0">
+          <a:p>
+            <a:pPr algn="l" indent="0" marL="0">
+              <a:lnSpc>
+                <a:spcPts val="1650"/>
+              </a:lnSpc>
               <a:buNone/>
             </a:pPr>
             <a:r>
@@ -5731,6 +5702,9 @@
               <a:t>'BIM 전환설계'</a:t>
             </a:r>
             <a:pPr algn="l" indent="0" marL="0">
+              <a:lnSpc>
+                <a:spcPts val="1650"/>
+              </a:lnSpc>
               <a:buNone/>
             </a:pPr>
             <a:r>
@@ -5750,7 +5724,7 @@
       </p:sp>
       <p:sp>
         <p:nvSpPr>
-          <p:cNvPr id="115" name="설계 후반 투입 인력 증가·추가 비용"/>
+          <p:cNvPr id="113" name="설계 후반 투입 인력 증가·추가 비용"/>
           <p:cNvSpPr txBox="1"/>
           <p:nvPr/>
         </p:nvSpPr>
@@ -5789,7 +5763,7 @@
       </p:sp>
       <p:sp>
         <p:nvSpPr>
-          <p:cNvPr id="116" name="출처: 진상윤, 「BIM은 독일까? 득일까?」, 건축문화신문, 2015"/>
+          <p:cNvPr id="114" name="출처: 진상윤, 「BIM은 독일까? 득일까?」, 건축문화신문, 2015"/>
           <p:cNvSpPr txBox="1"/>
           <p:nvPr/>
         </p:nvSpPr>
@@ -5828,7 +5802,7 @@
       </p:sp>
       <p:sp>
         <p:nvSpPr>
-          <p:cNvPr id="117" name="기존 건축물"/>
+          <p:cNvPr id="115" name="기존 건축물"/>
           <p:cNvSpPr txBox="1"/>
           <p:nvPr/>
         </p:nvSpPr>
@@ -5867,7 +5841,7 @@
       </p:sp>
       <p:sp>
         <p:nvSpPr>
-          <p:cNvPr id="118" name="BIM 없이 2D 도면만 남아 있음"/>
+          <p:cNvPr id="116" name="BIM 없이 2D 도면만 남아 있음"/>
           <p:cNvSpPr txBox="1"/>
           <p:nvPr/>
         </p:nvSpPr>
@@ -5934,7 +5908,7 @@
       </p:sp>
       <p:sp>
         <p:nvSpPr>
-          <p:cNvPr id="119" name="2D 도면으로 3D BIM을 새로 구축해야 함"/>
+          <p:cNvPr id="117" name="2D 도면으로 3D BIM을 새로 구축해야 함"/>
           <p:cNvSpPr txBox="1"/>
           <p:nvPr/>
         </p:nvSpPr>
@@ -5973,7 +5947,7 @@
       </p:sp>
       <p:sp>
         <p:nvSpPr>
-          <p:cNvPr id="120" name="문제"/>
+          <p:cNvPr id="118" name="문제"/>
           <p:cNvSpPr txBox="1"/>
           <p:nvPr/>
         </p:nvSpPr>
@@ -6012,7 +5986,7 @@
       </p:sp>
       <p:sp>
         <p:nvSpPr>
-          <p:cNvPr id="121" name="사람이 도면을 보고 직접 모델링"/>
+          <p:cNvPr id="119" name="사람이 도면을 보고 직접 모델링"/>
           <p:cNvSpPr txBox="1"/>
           <p:nvPr/>
         </p:nvSpPr>
@@ -6051,7 +6025,7 @@
       </p:sp>
       <p:sp>
         <p:nvSpPr>
-          <p:cNvPr id="122" name="평면도 · 입면도"/>
+          <p:cNvPr id="120" name="평면도 · 입면도"/>
           <p:cNvSpPr txBox="1"/>
           <p:nvPr/>
         </p:nvSpPr>
@@ -6090,7 +6064,7 @@
       </p:sp>
       <p:sp>
         <p:nvSpPr>
-          <p:cNvPr id="123" name="도면 해석 · 직접 입력"/>
+          <p:cNvPr id="121" name="도면 해석 · 직접 입력"/>
           <p:cNvSpPr txBox="1"/>
           <p:nvPr/>
         </p:nvSpPr>
@@ -6129,7 +6103,7 @@
       </p:sp>
       <p:sp>
         <p:nvSpPr>
-          <p:cNvPr id="124" name="수작업 모델링 예시"/>
+          <p:cNvPr id="122" name="수작업 모델링 예시"/>
           <p:cNvSpPr txBox="1"/>
           <p:nvPr/>
         </p:nvSpPr>
@@ -6168,7 +6142,7 @@
       </p:sp>
       <p:sp>
         <p:nvSpPr>
-          <p:cNvPr id="125" name="1"/>
+          <p:cNvPr id="123" name="1"/>
           <p:cNvSpPr txBox="1"/>
           <p:nvPr/>
         </p:nvSpPr>
@@ -6207,7 +6181,7 @@
       </p:sp>
       <p:sp>
         <p:nvSpPr>
-          <p:cNvPr id="126" name="노동집약적 작업"/>
+          <p:cNvPr id="124" name="노동집약적 작업"/>
           <p:cNvSpPr txBox="1"/>
           <p:nvPr/>
         </p:nvSpPr>
@@ -6246,7 +6220,7 @@
       </p:sp>
       <p:sp>
         <p:nvSpPr>
-          <p:cNvPr id="127" name="도면을 한 장씩 보며 벽·창·문을 직접 입력"/>
+          <p:cNvPr id="125" name="도면을 한 장씩 보며 벽·창·문을 직접 입력"/>
           <p:cNvSpPr txBox="1"/>
           <p:nvPr/>
         </p:nvSpPr>
@@ -6285,7 +6259,7 @@
       </p:sp>
       <p:sp>
         <p:nvSpPr>
-          <p:cNvPr id="128" name="2"/>
+          <p:cNvPr id="126" name="2"/>
           <p:cNvSpPr txBox="1"/>
           <p:nvPr/>
         </p:nvSpPr>
@@ -6324,7 +6298,7 @@
       </p:sp>
       <p:sp>
         <p:nvSpPr>
-          <p:cNvPr id="129" name="긴 작업 시간 · 높은 비용"/>
+          <p:cNvPr id="127" name="긴 작업 시간 · 높은 비용"/>
           <p:cNvSpPr txBox="1"/>
           <p:nvPr/>
         </p:nvSpPr>
@@ -6363,7 +6337,7 @@
       </p:sp>
       <p:sp>
         <p:nvSpPr>
-          <p:cNvPr id="130" name="건물 규모에 비례해 모델링 시간과 비용 증가"/>
+          <p:cNvPr id="128" name="건물 규모에 비례해 모델링 시간과 비용 증가"/>
           <p:cNvSpPr txBox="1"/>
           <p:nvPr/>
         </p:nvSpPr>
@@ -6402,7 +6376,7 @@
       </p:sp>
       <p:sp>
         <p:nvSpPr>
-          <p:cNvPr id="131" name="3"/>
+          <p:cNvPr id="129" name="3"/>
           <p:cNvSpPr txBox="1"/>
           <p:nvPr/>
         </p:nvSpPr>
@@ -6441,7 +6415,7 @@
       </p:sp>
       <p:sp>
         <p:nvSpPr>
-          <p:cNvPr id="132" name="휴먼 에러 가능성"/>
+          <p:cNvPr id="130" name="휴먼 에러 가능성"/>
           <p:cNvSpPr txBox="1"/>
           <p:nvPr/>
         </p:nvSpPr>
@@ -6480,7 +6454,7 @@
       </p:sp>
       <p:sp>
         <p:nvSpPr>
-          <p:cNvPr id="133" name="도면 해석·입력 과정에서 누락과 오류 발생"/>
+          <p:cNvPr id="131" name="도면 해석·입력 과정에서 누락과 오류 발생"/>
           <p:cNvSpPr txBox="1"/>
           <p:nvPr/>
         </p:nvSpPr>
@@ -6519,7 +6493,7 @@
       </p:sp>
       <p:sp>
         <p:nvSpPr>
-          <p:cNvPr id="134" name="KEY MESSAGE"/>
+          <p:cNvPr id="132" name="KEY MESSAGE"/>
           <p:cNvSpPr txBox="1"/>
           <p:nvPr/>
         </p:nvSpPr>
@@ -6558,7 +6532,7 @@
       </p:sp>
       <p:sp>
         <p:nvSpPr>
-          <p:cNvPr id="135" name="2차원 도면에 기반한 3차원 BIM 모델 자동 생성 프로세스가 필요합니다"/>
+          <p:cNvPr id="133" name="2차원 도면에 기반한 3차원 BIM 모델 자동 생성 프로세스가 필요합니다"/>
           <p:cNvSpPr txBox="1"/>
           <p:nvPr/>
         </p:nvSpPr>
@@ -6625,7 +6599,7 @@
       </p:sp>
       <p:sp>
         <p:nvSpPr>
-          <p:cNvPr id="136" name="석사 연구 발표  ·  평면도와 입면도 객체 인식 및 정보 통합을 통한 "/>
+          <p:cNvPr id="134" name="석사 연구 발표  ·  평면도와 입면도 객체 인식 및 정보 통합을 통한 "/>
           <p:cNvSpPr txBox="1"/>
           <p:nvPr/>
         </p:nvSpPr>
@@ -6664,7 +6638,7 @@
       </p:sp>
       <p:sp>
         <p:nvSpPr>
-          <p:cNvPr id="137" name="01 / 05"/>
+          <p:cNvPr id="135" name="01 / 05"/>
           <p:cNvSpPr txBox="1"/>
           <p:nvPr/>
         </p:nvSpPr>
@@ -8861,14 +8835,14 @@
       </p:sp>
       <p:sp>
         <p:nvSpPr>
-          <p:cNvPr id="56" name="기존 연구의 세 가지 한계를"/>
+          <p:cNvPr id="56" name="기존 연구의 세 가지 한계를세 가지 연구 목표로 하나씩 해결합니다."/>
           <p:cNvSpPr txBox="1"/>
           <p:nvPr/>
         </p:nvSpPr>
         <p:spPr>
           <a:xfrm>
-            <a:off x="609600" y="666750"/>
-            <a:ext cx="3034840" cy="349250"/>
+            <a:off x="609600" y="653852"/>
+            <a:ext cx="4445826" cy="724297"/>
           </a:xfrm>
           <a:prstGeom prst="rect">
             <a:avLst/>
@@ -8877,10 +8851,13 @@
           <a:ln/>
         </p:spPr>
         <p:txBody>
-          <a:bodyPr wrap="none" lIns="0" tIns="0" rIns="0" bIns="0" rtlCol="0" anchor="ctr"/>
-          <a:lstStyle/>
-          <a:p>
-            <a:pPr algn="l" indent="0" marL="0">
+          <a:bodyPr wrap="none" lIns="0" tIns="0" rIns="0" bIns="0" rtlCol="0" anchor="t"/>
+          <a:lstStyle/>
+          <a:p>
+            <a:pPr algn="l" indent="0" marL="0">
+              <a:lnSpc>
+                <a:spcPts val="2852"/>
+              </a:lnSpc>
               <a:buNone/>
             </a:pPr>
             <a:r>
@@ -8896,30 +8873,11 @@
             </a:r>
             <a:endParaRPr lang="en-US" sz="2300" dirty="0"/>
           </a:p>
-        </p:txBody>
-      </p:sp>
-      <p:sp>
-        <p:nvSpPr>
-          <p:cNvPr id="57" name="세 가지 연구 목표로 하나씩 해결합니다."/>
-          <p:cNvSpPr txBox="1"/>
-          <p:nvPr/>
-        </p:nvSpPr>
-        <p:spPr>
-          <a:xfrm>
-            <a:off x="609600" y="1028898"/>
-            <a:ext cx="4445826" cy="349250"/>
-          </a:xfrm>
-          <a:prstGeom prst="rect">
-            <a:avLst/>
-          </a:prstGeom>
-          <a:noFill/>
-          <a:ln/>
-        </p:spPr>
-        <p:txBody>
-          <a:bodyPr wrap="none" lIns="0" tIns="0" rIns="0" bIns="0" rtlCol="0" anchor="ctr"/>
-          <a:lstStyle/>
-          <a:p>
-            <a:pPr algn="l" indent="0" marL="0">
+          <a:p>
+            <a:pPr algn="l" indent="0" marL="0">
+              <a:lnSpc>
+                <a:spcPts val="2852"/>
+              </a:lnSpc>
               <a:buNone/>
             </a:pPr>
             <a:r>
@@ -8934,6 +8892,9 @@
               <a:t>세 가지 연구 목표</a:t>
             </a:r>
             <a:pPr algn="l" indent="0" marL="0">
+              <a:lnSpc>
+                <a:spcPts val="2852"/>
+              </a:lnSpc>
               <a:buNone/>
             </a:pPr>
             <a:r>
@@ -8953,7 +8914,7 @@
       </p:sp>
       <p:sp>
         <p:nvSpPr>
-          <p:cNvPr id="58" name="01"/>
+          <p:cNvPr id="57" name="01"/>
           <p:cNvSpPr txBox="1"/>
           <p:nvPr/>
         </p:nvSpPr>
@@ -8992,7 +8953,7 @@
       </p:sp>
       <p:sp>
         <p:nvSpPr>
-          <p:cNvPr id="59" name="02"/>
+          <p:cNvPr id="58" name="02"/>
           <p:cNvSpPr txBox="1"/>
           <p:nvPr/>
         </p:nvSpPr>
@@ -9031,7 +8992,7 @@
       </p:sp>
       <p:sp>
         <p:nvSpPr>
-          <p:cNvPr id="60" name="03"/>
+          <p:cNvPr id="59" name="03"/>
           <p:cNvSpPr txBox="1"/>
           <p:nvPr/>
         </p:nvSpPr>
@@ -9070,7 +9031,7 @@
       </p:sp>
       <p:sp>
         <p:nvSpPr>
-          <p:cNvPr id="61" name="04"/>
+          <p:cNvPr id="60" name="04"/>
           <p:cNvSpPr txBox="1"/>
           <p:nvPr/>
         </p:nvSpPr>
@@ -9109,7 +9070,7 @@
       </p:sp>
       <p:sp>
         <p:nvSpPr>
-          <p:cNvPr id="62" name="05"/>
+          <p:cNvPr id="61" name="05"/>
           <p:cNvSpPr txBox="1"/>
           <p:nvPr/>
         </p:nvSpPr>
@@ -9148,7 +9109,7 @@
       </p:sp>
       <p:sp>
         <p:nvSpPr>
-          <p:cNvPr id="63" name="쟁점"/>
+          <p:cNvPr id="62" name="쟁점"/>
           <p:cNvSpPr txBox="1"/>
           <p:nvPr/>
         </p:nvSpPr>
@@ -9187,7 +9148,7 @@
       </p:sp>
       <p:sp>
         <p:nvSpPr>
-          <p:cNvPr id="64" name="기존 연구의 한계"/>
+          <p:cNvPr id="63" name="기존 연구의 한계"/>
           <p:cNvSpPr txBox="1"/>
           <p:nvPr/>
         </p:nvSpPr>
@@ -9226,7 +9187,7 @@
       </p:sp>
       <p:sp>
         <p:nvSpPr>
-          <p:cNvPr id="65" name="연구 목표"/>
+          <p:cNvPr id="64" name="연구 목표"/>
           <p:cNvSpPr txBox="1"/>
           <p:nvPr/>
         </p:nvSpPr>
@@ -9265,7 +9226,7 @@
       </p:sp>
       <p:sp>
         <p:nvSpPr>
-          <p:cNvPr id="66" name="높이 정보"/>
+          <p:cNvPr id="65" name="높이 정보"/>
           <p:cNvSpPr txBox="1"/>
           <p:nvPr/>
         </p:nvSpPr>
@@ -9304,7 +9265,7 @@
       </p:sp>
       <p:sp>
         <p:nvSpPr>
-          <p:cNvPr id="67" name="한계 1"/>
+          <p:cNvPr id="66" name="한계 1"/>
           <p:cNvSpPr txBox="1"/>
           <p:nvPr/>
         </p:nvSpPr>
@@ -9343,7 +9304,7 @@
       </p:sp>
       <p:sp>
         <p:nvSpPr>
-          <p:cNvPr id="68" name="평면도 한 장만 사용"/>
+          <p:cNvPr id="67" name="평면도 한 장만 사용"/>
           <p:cNvSpPr txBox="1"/>
           <p:nvPr/>
         </p:nvSpPr>
@@ -9382,7 +9343,7 @@
       </p:sp>
       <p:sp>
         <p:nvSpPr>
-          <p:cNvPr id="69" name="높이 정보를 알 수 없음 (수동 입력·고정값)"/>
+          <p:cNvPr id="68" name="높이 정보를 알 수 없음 (수동 입력·고정값)"/>
           <p:cNvSpPr txBox="1"/>
           <p:nvPr/>
         </p:nvSpPr>
@@ -9421,7 +9382,7 @@
       </p:sp>
       <p:sp>
         <p:nvSpPr>
-          <p:cNvPr id="70" name="목표 1"/>
+          <p:cNvPr id="69" name="목표 1"/>
           <p:cNvSpPr txBox="1"/>
           <p:nvPr/>
         </p:nvSpPr>
@@ -9460,7 +9421,7 @@
       </p:sp>
       <p:sp>
         <p:nvSpPr>
-          <p:cNvPr id="71" name="평면도와 입면도 정보를 통합해"/>
+          <p:cNvPr id="70" name="평면도와 입면도 정보를 통합해"/>
           <p:cNvSpPr txBox="1"/>
           <p:nvPr/>
         </p:nvSpPr>
@@ -9499,7 +9460,7 @@
       </p:sp>
       <p:sp>
         <p:nvSpPr>
-          <p:cNvPr id="72" name="완전한 3차원 BIM 생성"/>
+          <p:cNvPr id="71" name="완전한 3차원 BIM 생성"/>
           <p:cNvSpPr txBox="1"/>
           <p:nvPr/>
         </p:nvSpPr>
@@ -9538,7 +9499,7 @@
       </p:sp>
       <p:sp>
         <p:nvSpPr>
-          <p:cNvPr id="73" name="CAD 의존"/>
+          <p:cNvPr id="72" name="CAD 의존"/>
           <p:cNvSpPr txBox="1"/>
           <p:nvPr/>
         </p:nvSpPr>
@@ -9577,7 +9538,7 @@
       </p:sp>
       <p:sp>
         <p:nvSpPr>
-          <p:cNvPr id="74" name="한계 2"/>
+          <p:cNvPr id="73" name="한계 2"/>
           <p:cNvSpPr txBox="1"/>
           <p:nvPr/>
         </p:nvSpPr>
@@ -9616,7 +9577,7 @@
       </p:sp>
       <p:sp>
         <p:nvSpPr>
-          <p:cNvPr id="75" name="CAD 레이어·블록 같은 정보에 의존"/>
+          <p:cNvPr id="74" name="CAD 레이어·블록 같은 정보에 의존"/>
           <p:cNvSpPr txBox="1"/>
           <p:nvPr/>
         </p:nvSpPr>
@@ -9655,7 +9616,7 @@
       </p:sp>
       <p:sp>
         <p:nvSpPr>
-          <p:cNvPr id="76" name="이미지로만 남은 실제 도면에는 적용 불가"/>
+          <p:cNvPr id="75" name="이미지로만 남은 실제 도면에는 적용 불가"/>
           <p:cNvSpPr txBox="1"/>
           <p:nvPr/>
         </p:nvSpPr>
@@ -9694,7 +9655,7 @@
       </p:sp>
       <p:sp>
         <p:nvSpPr>
-          <p:cNvPr id="77" name="목표 2"/>
+          <p:cNvPr id="76" name="목표 2"/>
           <p:cNvSpPr txBox="1"/>
           <p:nvPr/>
         </p:nvSpPr>
@@ -9733,7 +9694,7 @@
       </p:sp>
       <p:sp>
         <p:nvSpPr>
-          <p:cNvPr id="78" name="CAD 정보 없이 이미지만으로"/>
+          <p:cNvPr id="77" name="CAD 정보 없이 이미지만으로"/>
           <p:cNvSpPr txBox="1"/>
           <p:nvPr/>
         </p:nvSpPr>
@@ -9772,7 +9733,7 @@
       </p:sp>
       <p:sp>
         <p:nvSpPr>
-          <p:cNvPr id="79" name="평면도·입면도 간 대응 객체 정의"/>
+          <p:cNvPr id="78" name="평면도·입면도 간 대응 객체 정의"/>
           <p:cNvSpPr txBox="1"/>
           <p:nvPr/>
         </p:nvSpPr>
@@ -9811,7 +9772,7 @@
       </p:sp>
       <p:sp>
         <p:nvSpPr>
-          <p:cNvPr id="80" name="치수 의존"/>
+          <p:cNvPr id="79" name="치수 의존"/>
           <p:cNvSpPr txBox="1"/>
           <p:nvPr/>
         </p:nvSpPr>
@@ -9850,7 +9811,7 @@
       </p:sp>
       <p:sp>
         <p:nvSpPr>
-          <p:cNvPr id="81" name="한계 3"/>
+          <p:cNvPr id="80" name="한계 3"/>
           <p:cNvSpPr txBox="1"/>
           <p:nvPr/>
         </p:nvSpPr>
@@ -9889,7 +9850,7 @@
       </p:sp>
       <p:sp>
         <p:nvSpPr>
-          <p:cNvPr id="82" name="치수 글자 인식(OCR)에 의존"/>
+          <p:cNvPr id="81" name="치수 글자 인식(OCR)에 의존"/>
           <p:cNvSpPr txBox="1"/>
           <p:nvPr/>
         </p:nvSpPr>
@@ -9928,7 +9889,7 @@
       </p:sp>
       <p:sp>
         <p:nvSpPr>
-          <p:cNvPr id="83" name="치수가 빠지거나 겹치면 부정확"/>
+          <p:cNvPr id="82" name="치수가 빠지거나 겹치면 부정확"/>
           <p:cNvSpPr txBox="1"/>
           <p:nvPr/>
         </p:nvSpPr>
@@ -9967,7 +9928,7 @@
       </p:sp>
       <p:sp>
         <p:nvSpPr>
-          <p:cNvPr id="84" name="목표 3"/>
+          <p:cNvPr id="83" name="목표 3"/>
           <p:cNvSpPr txBox="1"/>
           <p:nvPr/>
         </p:nvSpPr>
@@ -10006,7 +9967,7 @@
       </p:sp>
       <p:sp>
         <p:nvSpPr>
-          <p:cNvPr id="85" name="LMM(대형 멀티모달 모델)으로 축척을 인식해"/>
+          <p:cNvPr id="84" name="LMM(대형 멀티모달 모델)으로 축척을 인식해"/>
           <p:cNvSpPr txBox="1"/>
           <p:nvPr/>
         </p:nvSpPr>
@@ -10045,7 +10006,7 @@
       </p:sp>
       <p:sp>
         <p:nvSpPr>
-          <p:cNvPr id="86" name="안정적으로 치수 보정"/>
+          <p:cNvPr id="85" name="안정적으로 치수 보정"/>
           <p:cNvSpPr txBox="1"/>
           <p:nvPr/>
         </p:nvSpPr>
@@ -10084,7 +10045,7 @@
       </p:sp>
       <p:sp>
         <p:nvSpPr>
-          <p:cNvPr id="87" name="KEY MESSAGE"/>
+          <p:cNvPr id="86" name="KEY MESSAGE"/>
           <p:cNvSpPr txBox="1"/>
           <p:nvPr/>
         </p:nvSpPr>
@@ -10123,14 +10084,14 @@
       </p:sp>
       <p:sp>
         <p:nvSpPr>
-          <p:cNvPr id="88" name="딥러닝 기반 도면 객체 인식과 평면도·입면도 간 직접 매칭으로,"/>
+          <p:cNvPr id="87" name="딥러닝 기반 도면 객체 인식과 평면도·입면도 간 직접 매칭으로,정확한 3"/>
           <p:cNvSpPr txBox="1"/>
           <p:nvPr/>
         </p:nvSpPr>
         <p:spPr>
           <a:xfrm>
-            <a:off x="1854994" y="5755680"/>
-            <a:ext cx="4142615" cy="209550"/>
+            <a:off x="1854994" y="5725220"/>
+            <a:ext cx="4142615" cy="480020"/>
           </a:xfrm>
           <a:prstGeom prst="rect">
             <a:avLst/>
@@ -10139,10 +10100,13 @@
           <a:ln/>
         </p:spPr>
         <p:txBody>
-          <a:bodyPr wrap="none" lIns="0" tIns="0" rIns="0" bIns="0" rtlCol="0" anchor="ctr"/>
-          <a:lstStyle/>
-          <a:p>
-            <a:pPr algn="l" indent="0" marL="0">
+          <a:bodyPr wrap="none" lIns="0" tIns="0" rIns="0" bIns="0" rtlCol="0" anchor="t"/>
+          <a:lstStyle/>
+          <a:p>
+            <a:pPr algn="l" indent="0" marL="0">
+              <a:lnSpc>
+                <a:spcPts val="1890"/>
+              </a:lnSpc>
               <a:buNone/>
             </a:pPr>
             <a:r>
@@ -10158,30 +10122,11 @@
             </a:r>
             <a:endParaRPr lang="en-US" sz="1350" dirty="0"/>
           </a:p>
-        </p:txBody>
-      </p:sp>
-      <p:sp>
-        <p:nvSpPr>
-          <p:cNvPr id="89" name="정확한 3차원 정보를 가진 BIM 자동 생성 방법을 제안합니다."/>
-          <p:cNvSpPr txBox="1"/>
-          <p:nvPr/>
-        </p:nvSpPr>
-        <p:spPr>
-          <a:xfrm>
-            <a:off x="1854994" y="5995690"/>
-            <a:ext cx="4059845" cy="209550"/>
-          </a:xfrm>
-          <a:prstGeom prst="rect">
-            <a:avLst/>
-          </a:prstGeom>
-          <a:noFill/>
-          <a:ln/>
-        </p:spPr>
-        <p:txBody>
-          <a:bodyPr wrap="none" lIns="0" tIns="0" rIns="0" bIns="0" rtlCol="0" anchor="ctr"/>
-          <a:lstStyle/>
-          <a:p>
-            <a:pPr algn="l" indent="0" marL="0">
+          <a:p>
+            <a:pPr algn="l" indent="0" marL="0">
+              <a:lnSpc>
+                <a:spcPts val="1890"/>
+              </a:lnSpc>
               <a:buNone/>
             </a:pPr>
             <a:r>
@@ -10196,6 +10141,9 @@
               <a:t>정확한 3차원 정보를 가진 BIM 자동 생성 방법</a:t>
             </a:r>
             <a:pPr algn="l" indent="0" marL="0">
+              <a:lnSpc>
+                <a:spcPts val="1890"/>
+              </a:lnSpc>
               <a:buNone/>
             </a:pPr>
             <a:r>
@@ -10215,7 +10163,7 @@
       </p:sp>
       <p:sp>
         <p:nvSpPr>
-          <p:cNvPr id="90" name="석사 연구 발표  ·  평면도와 입면도 객체 인식 및 정보 통합을 통한 "/>
+          <p:cNvPr id="88" name="석사 연구 발표  ·  평면도와 입면도 객체 인식 및 정보 통합을 통한 "/>
           <p:cNvSpPr txBox="1"/>
           <p:nvPr/>
         </p:nvSpPr>
@@ -10254,7 +10202,7 @@
       </p:sp>
       <p:sp>
         <p:nvSpPr>
-          <p:cNvPr id="91" name="02 / 05"/>
+          <p:cNvPr id="89" name="02 / 05"/>
           <p:cNvSpPr txBox="1"/>
           <p:nvPr/>
         </p:nvSpPr>
@@ -11804,14 +11752,14 @@
       </p:sp>
       <p:sp>
         <p:nvSpPr>
-          <p:cNvPr id="45" name="도면 이미지만으로 객체 인식부터 BIM 생성까지"/>
+          <p:cNvPr id="45" name="도면 이미지만으로 객체 인식부터 BIM 생성까지전 과정을 자동화했습니다."/>
           <p:cNvSpPr txBox="1"/>
           <p:nvPr/>
         </p:nvSpPr>
         <p:spPr>
           <a:xfrm>
-            <a:off x="609600" y="666750"/>
-            <a:ext cx="5400681" cy="349250"/>
+            <a:off x="609600" y="653852"/>
+            <a:ext cx="5400681" cy="724297"/>
           </a:xfrm>
           <a:prstGeom prst="rect">
             <a:avLst/>
@@ -11820,10 +11768,13 @@
           <a:ln/>
         </p:spPr>
         <p:txBody>
-          <a:bodyPr wrap="none" lIns="0" tIns="0" rIns="0" bIns="0" rtlCol="0" anchor="ctr"/>
-          <a:lstStyle/>
-          <a:p>
-            <a:pPr algn="l" indent="0" marL="0">
+          <a:bodyPr wrap="none" lIns="0" tIns="0" rIns="0" bIns="0" rtlCol="0" anchor="t"/>
+          <a:lstStyle/>
+          <a:p>
+            <a:pPr algn="l" indent="0" marL="0">
+              <a:lnSpc>
+                <a:spcPts val="2852"/>
+              </a:lnSpc>
               <a:buNone/>
             </a:pPr>
             <a:r>
@@ -11839,30 +11790,11 @@
             </a:r>
             <a:endParaRPr lang="en-US" sz="2300" dirty="0"/>
           </a:p>
-        </p:txBody>
-      </p:sp>
-      <p:sp>
-        <p:nvSpPr>
-          <p:cNvPr id="46" name="전 과정을 자동화했습니다."/>
-          <p:cNvSpPr txBox="1"/>
-          <p:nvPr/>
-        </p:nvSpPr>
-        <p:spPr>
-          <a:xfrm>
-            <a:off x="609600" y="1028898"/>
-            <a:ext cx="2999186" cy="349250"/>
-          </a:xfrm>
-          <a:prstGeom prst="rect">
-            <a:avLst/>
-          </a:prstGeom>
-          <a:noFill/>
-          <a:ln/>
-        </p:spPr>
-        <p:txBody>
-          <a:bodyPr wrap="none" lIns="0" tIns="0" rIns="0" bIns="0" rtlCol="0" anchor="ctr"/>
-          <a:lstStyle/>
-          <a:p>
-            <a:pPr algn="l" indent="0" marL="0">
+          <a:p>
+            <a:pPr algn="l" indent="0" marL="0">
+              <a:lnSpc>
+                <a:spcPts val="2852"/>
+              </a:lnSpc>
               <a:buNone/>
             </a:pPr>
             <a:r>
@@ -11877,6 +11809,9 @@
               <a:t>전 과정을 자동화</a:t>
             </a:r>
             <a:pPr algn="l" indent="0" marL="0">
+              <a:lnSpc>
+                <a:spcPts val="2852"/>
+              </a:lnSpc>
               <a:buNone/>
             </a:pPr>
             <a:r>
@@ -11896,7 +11831,7 @@
       </p:sp>
       <p:sp>
         <p:nvSpPr>
-          <p:cNvPr id="47" name="01"/>
+          <p:cNvPr id="46" name="01"/>
           <p:cNvSpPr txBox="1"/>
           <p:nvPr/>
         </p:nvSpPr>
@@ -11935,7 +11870,7 @@
       </p:sp>
       <p:sp>
         <p:nvSpPr>
-          <p:cNvPr id="48" name="02"/>
+          <p:cNvPr id="47" name="02"/>
           <p:cNvSpPr txBox="1"/>
           <p:nvPr/>
         </p:nvSpPr>
@@ -11974,7 +11909,7 @@
       </p:sp>
       <p:sp>
         <p:nvSpPr>
-          <p:cNvPr id="49" name="03"/>
+          <p:cNvPr id="48" name="03"/>
           <p:cNvSpPr txBox="1"/>
           <p:nvPr/>
         </p:nvSpPr>
@@ -12013,7 +11948,7 @@
       </p:sp>
       <p:sp>
         <p:nvSpPr>
-          <p:cNvPr id="50" name="04"/>
+          <p:cNvPr id="49" name="04"/>
           <p:cNvSpPr txBox="1"/>
           <p:nvPr/>
         </p:nvSpPr>
@@ -12052,7 +11987,7 @@
       </p:sp>
       <p:sp>
         <p:nvSpPr>
-          <p:cNvPr id="51" name="05"/>
+          <p:cNvPr id="50" name="05"/>
           <p:cNvSpPr txBox="1"/>
           <p:nvPr/>
         </p:nvSpPr>
@@ -12091,7 +12026,7 @@
       </p:sp>
       <p:sp>
         <p:nvSpPr>
-          <p:cNvPr id="52" name="도면 해석"/>
+          <p:cNvPr id="51" name="도면 해석"/>
           <p:cNvSpPr txBox="1"/>
           <p:nvPr/>
         </p:nvSpPr>
@@ -12130,7 +12065,7 @@
       </p:sp>
       <p:sp>
         <p:nvSpPr>
-          <p:cNvPr id="53" name="3D 재구성"/>
+          <p:cNvPr id="52" name="3D 재구성"/>
           <p:cNvSpPr txBox="1"/>
           <p:nvPr/>
         </p:nvSpPr>
@@ -12169,7 +12104,7 @@
       </p:sp>
       <p:sp>
         <p:nvSpPr>
-          <p:cNvPr id="54" name="STEP 1"/>
+          <p:cNvPr id="53" name="STEP 1"/>
           <p:cNvSpPr txBox="1"/>
           <p:nvPr/>
         </p:nvSpPr>
@@ -12208,7 +12143,7 @@
       </p:sp>
       <p:sp>
         <p:nvSpPr>
-          <p:cNvPr id="55" name="도면 이미지 입력"/>
+          <p:cNvPr id="54" name="도면 이미지 입력"/>
           <p:cNvSpPr txBox="1"/>
           <p:nvPr/>
         </p:nvSpPr>
@@ -12247,7 +12182,7 @@
       </p:sp>
       <p:sp>
         <p:nvSpPr>
-          <p:cNvPr id="56" name="평면도·입면도 이미지만 입력"/>
+          <p:cNvPr id="55" name="평면도·입면도 이미지만 입력"/>
           <p:cNvSpPr txBox="1"/>
           <p:nvPr/>
         </p:nvSpPr>
@@ -12286,7 +12221,7 @@
       </p:sp>
       <p:sp>
         <p:nvSpPr>
-          <p:cNvPr id="57" name="평면도"/>
+          <p:cNvPr id="56" name="평면도"/>
           <p:cNvSpPr txBox="1"/>
           <p:nvPr/>
         </p:nvSpPr>
@@ -12325,7 +12260,7 @@
       </p:sp>
       <p:sp>
         <p:nvSpPr>
-          <p:cNvPr id="58" name="창·문의 평면 위치 X·Y"/>
+          <p:cNvPr id="57" name="창·문의 평면 위치 X·Y"/>
           <p:cNvSpPr txBox="1"/>
           <p:nvPr/>
         </p:nvSpPr>
@@ -12378,7 +12313,7 @@
       </p:sp>
       <p:sp>
         <p:nvSpPr>
-          <p:cNvPr id="59" name="입면도"/>
+          <p:cNvPr id="58" name="입면도"/>
           <p:cNvSpPr txBox="1"/>
           <p:nvPr/>
         </p:nvSpPr>
@@ -12417,7 +12352,7 @@
       </p:sp>
       <p:sp>
         <p:nvSpPr>
-          <p:cNvPr id="60" name="창·문이 놓인 높이 Z"/>
+          <p:cNvPr id="59" name="창·문이 놓인 높이 Z"/>
           <p:cNvSpPr txBox="1"/>
           <p:nvPr/>
         </p:nvSpPr>
@@ -12470,7 +12405,7 @@
       </p:sp>
       <p:sp>
         <p:nvSpPr>
-          <p:cNvPr id="61" name="입력 형식"/>
+          <p:cNvPr id="60" name="입력 형식"/>
           <p:cNvSpPr txBox="1"/>
           <p:nvPr/>
         </p:nvSpPr>
@@ -12509,7 +12444,7 @@
       </p:sp>
       <p:sp>
         <p:nvSpPr>
-          <p:cNvPr id="62" name="래스터 이미지"/>
+          <p:cNvPr id="61" name="래스터 이미지"/>
           <p:cNvSpPr txBox="1"/>
           <p:nvPr/>
         </p:nvSpPr>
@@ -12548,7 +12483,7 @@
       </p:sp>
       <p:sp>
         <p:nvSpPr>
-          <p:cNvPr id="63" name="(픽셀 기반)"/>
+          <p:cNvPr id="62" name="(픽셀 기반)"/>
           <p:cNvSpPr txBox="1"/>
           <p:nvPr/>
         </p:nvSpPr>
@@ -12587,7 +12522,7 @@
       </p:sp>
       <p:sp>
         <p:nvSpPr>
-          <p:cNvPr id="64" name="STEP 2"/>
+          <p:cNvPr id="63" name="STEP 2"/>
           <p:cNvSpPr txBox="1"/>
           <p:nvPr/>
         </p:nvSpPr>
@@ -12626,7 +12561,7 @@
       </p:sp>
       <p:sp>
         <p:nvSpPr>
-          <p:cNvPr id="65" name="객체 인식"/>
+          <p:cNvPr id="64" name="객체 인식"/>
           <p:cNvSpPr txBox="1"/>
           <p:nvPr/>
         </p:nvSpPr>
@@ -12665,7 +12600,7 @@
       </p:sp>
       <p:sp>
         <p:nvSpPr>
-          <p:cNvPr id="66" name="도면 속 벽·창문·문 인식"/>
+          <p:cNvPr id="65" name="도면 속 벽·창문·문 인식"/>
           <p:cNvSpPr txBox="1"/>
           <p:nvPr/>
         </p:nvSpPr>
@@ -12704,7 +12639,7 @@
       </p:sp>
       <p:sp>
         <p:nvSpPr>
-          <p:cNvPr id="67" name="평면도"/>
+          <p:cNvPr id="66" name="평면도"/>
           <p:cNvSpPr txBox="1"/>
           <p:nvPr/>
         </p:nvSpPr>
@@ -12743,14 +12678,14 @@
       </p:sp>
       <p:sp>
         <p:nvSpPr>
-          <p:cNvPr id="68" name="외벽 창·문을 동·서·남·북"/>
+          <p:cNvPr id="67" name="외벽 창·문을 동·서·남·북방향별로 정리"/>
           <p:cNvSpPr txBox="1"/>
           <p:nvPr/>
         </p:nvSpPr>
         <p:spPr>
           <a:xfrm>
-            <a:off x="4000500" y="4502547"/>
-            <a:ext cx="1134594" cy="146050"/>
+            <a:off x="4000500" y="4470797"/>
+            <a:ext cx="1134594" cy="355600"/>
           </a:xfrm>
           <a:prstGeom prst="rect">
             <a:avLst/>
@@ -12759,10 +12694,13 @@
           <a:ln/>
         </p:spPr>
         <p:txBody>
-          <a:bodyPr wrap="none" lIns="0" tIns="0" rIns="0" bIns="0" rtlCol="0" anchor="ctr"/>
-          <a:lstStyle/>
-          <a:p>
-            <a:pPr algn="l" indent="0" marL="0">
+          <a:bodyPr wrap="none" lIns="0" tIns="0" rIns="0" bIns="0" rtlCol="0" anchor="t"/>
+          <a:lstStyle/>
+          <a:p>
+            <a:pPr algn="l" indent="0" marL="0">
+              <a:lnSpc>
+                <a:spcPts val="1400"/>
+              </a:lnSpc>
               <a:buNone/>
             </a:pPr>
             <a:r>
@@ -12778,30 +12716,11 @@
             </a:r>
             <a:endParaRPr lang="en-US" sz="950" dirty="0"/>
           </a:p>
-        </p:txBody>
-      </p:sp>
-      <p:sp>
-        <p:nvSpPr>
-          <p:cNvPr id="69" name="방향별로 정리"/>
-          <p:cNvSpPr txBox="1"/>
-          <p:nvPr/>
-        </p:nvSpPr>
-        <p:spPr>
-          <a:xfrm>
-            <a:off x="4000500" y="4680347"/>
-            <a:ext cx="678954" cy="146050"/>
-          </a:xfrm>
-          <a:prstGeom prst="rect">
-            <a:avLst/>
-          </a:prstGeom>
-          <a:noFill/>
-          <a:ln/>
-        </p:spPr>
-        <p:txBody>
-          <a:bodyPr wrap="none" lIns="0" tIns="0" rIns="0" bIns="0" rtlCol="0" anchor="ctr"/>
-          <a:lstStyle/>
-          <a:p>
-            <a:pPr algn="l" indent="0" marL="0">
+          <a:p>
+            <a:pPr algn="l" indent="0" marL="0">
+              <a:lnSpc>
+                <a:spcPts val="1400"/>
+              </a:lnSpc>
               <a:buNone/>
             </a:pPr>
             <a:r>
@@ -12821,7 +12740,7 @@
       </p:sp>
       <p:sp>
         <p:nvSpPr>
-          <p:cNvPr id="70" name="입면도"/>
+          <p:cNvPr id="68" name="입면도"/>
           <p:cNvSpPr txBox="1"/>
           <p:nvPr/>
         </p:nvSpPr>
@@ -12860,14 +12779,14 @@
       </p:sp>
       <p:sp>
         <p:nvSpPr>
-          <p:cNvPr id="71" name="같은 층 창·문끼리 묶어"/>
+          <p:cNvPr id="69" name="같은 층 창·문끼리 묶어층 높이 파악"/>
           <p:cNvSpPr txBox="1"/>
           <p:nvPr/>
         </p:nvSpPr>
         <p:spPr>
           <a:xfrm>
-            <a:off x="4000500" y="4908947"/>
-            <a:ext cx="1072332" cy="146050"/>
+            <a:off x="4000500" y="4877197"/>
+            <a:ext cx="1072332" cy="355600"/>
           </a:xfrm>
           <a:prstGeom prst="rect">
             <a:avLst/>
@@ -12876,10 +12795,13 @@
           <a:ln/>
         </p:spPr>
         <p:txBody>
-          <a:bodyPr wrap="none" lIns="0" tIns="0" rIns="0" bIns="0" rtlCol="0" anchor="ctr"/>
-          <a:lstStyle/>
-          <a:p>
-            <a:pPr algn="l" indent="0" marL="0">
+          <a:bodyPr wrap="none" lIns="0" tIns="0" rIns="0" bIns="0" rtlCol="0" anchor="t"/>
+          <a:lstStyle/>
+          <a:p>
+            <a:pPr algn="l" indent="0" marL="0">
+              <a:lnSpc>
+                <a:spcPts val="1400"/>
+              </a:lnSpc>
               <a:buNone/>
             </a:pPr>
             <a:r>
@@ -12895,30 +12817,11 @@
             </a:r>
             <a:endParaRPr lang="en-US" sz="950" dirty="0"/>
           </a:p>
-        </p:txBody>
-      </p:sp>
-      <p:sp>
-        <p:nvSpPr>
-          <p:cNvPr id="72" name="층 높이 파악"/>
-          <p:cNvSpPr txBox="1"/>
-          <p:nvPr/>
-        </p:nvSpPr>
-        <p:spPr>
-          <a:xfrm>
-            <a:off x="4000500" y="5086747"/>
-            <a:ext cx="602456" cy="146050"/>
-          </a:xfrm>
-          <a:prstGeom prst="rect">
-            <a:avLst/>
-          </a:prstGeom>
-          <a:noFill/>
-          <a:ln/>
-        </p:spPr>
-        <p:txBody>
-          <a:bodyPr wrap="none" lIns="0" tIns="0" rIns="0" bIns="0" rtlCol="0" anchor="ctr"/>
-          <a:lstStyle/>
-          <a:p>
-            <a:pPr algn="l" indent="0" marL="0">
+          <a:p>
+            <a:pPr algn="l" indent="0" marL="0">
+              <a:lnSpc>
+                <a:spcPts val="1400"/>
+              </a:lnSpc>
               <a:buNone/>
             </a:pPr>
             <a:r>
@@ -12938,7 +12841,7 @@
       </p:sp>
       <p:sp>
         <p:nvSpPr>
-          <p:cNvPr id="73" name="핵심 기법"/>
+          <p:cNvPr id="70" name="핵심 기법"/>
           <p:cNvSpPr txBox="1"/>
           <p:nvPr/>
         </p:nvSpPr>
@@ -12977,7 +12880,7 @@
       </p:sp>
       <p:sp>
         <p:nvSpPr>
-          <p:cNvPr id="74" name="YOLO + SAHI"/>
+          <p:cNvPr id="71" name="YOLO + SAHI"/>
           <p:cNvSpPr txBox="1"/>
           <p:nvPr/>
         </p:nvSpPr>
@@ -13016,7 +12919,7 @@
       </p:sp>
       <p:sp>
         <p:nvSpPr>
-          <p:cNvPr id="75" name="(작은 객체 분할 추론)"/>
+          <p:cNvPr id="72" name="(작은 객체 분할 추론)"/>
           <p:cNvSpPr txBox="1"/>
           <p:nvPr/>
         </p:nvSpPr>
@@ -13055,7 +12958,7 @@
       </p:sp>
       <p:sp>
         <p:nvSpPr>
-          <p:cNvPr id="76" name="DBSCAN 층별 클러스터링"/>
+          <p:cNvPr id="73" name="DBSCAN 층별 클러스터링"/>
           <p:cNvSpPr txBox="1"/>
           <p:nvPr/>
         </p:nvSpPr>
@@ -13094,7 +12997,7 @@
       </p:sp>
       <p:sp>
         <p:nvSpPr>
-          <p:cNvPr id="77" name="STEP 3"/>
+          <p:cNvPr id="74" name="STEP 3"/>
           <p:cNvSpPr txBox="1"/>
           <p:nvPr/>
         </p:nvSpPr>
@@ -13133,7 +13036,7 @@
       </p:sp>
       <p:sp>
         <p:nvSpPr>
-          <p:cNvPr id="78" name="대응 객체 매칭"/>
+          <p:cNvPr id="75" name="대응 객체 매칭"/>
           <p:cNvSpPr txBox="1"/>
           <p:nvPr/>
         </p:nvSpPr>
@@ -13172,7 +13075,7 @@
       </p:sp>
       <p:sp>
         <p:nvSpPr>
-          <p:cNvPr id="79" name="평면도·입면도의 같은 객체끼리 짝짓기"/>
+          <p:cNvPr id="76" name="평면도·입면도의 같은 객체끼리 짝짓기"/>
           <p:cNvSpPr txBox="1"/>
           <p:nvPr/>
         </p:nvSpPr>
@@ -13211,7 +13114,7 @@
       </p:sp>
       <p:sp>
         <p:nvSpPr>
-          <p:cNvPr id="80" name="축척"/>
+          <p:cNvPr id="77" name="축척"/>
           <p:cNvSpPr txBox="1"/>
           <p:nvPr/>
         </p:nvSpPr>
@@ -13250,14 +13153,14 @@
       </p:sp>
       <p:sp>
         <p:nvSpPr>
-          <p:cNvPr id="81" name="LMM(GPT-4o)이 축척을 읽어"/>
+          <p:cNvPr id="78" name="LMM(GPT-4o)이 축척을 읽어픽셀 → 실제 길이 환산"/>
           <p:cNvSpPr txBox="1"/>
           <p:nvPr/>
         </p:nvSpPr>
         <p:spPr>
           <a:xfrm>
-            <a:off x="6819900" y="4502547"/>
-            <a:ext cx="1483765" cy="146050"/>
+            <a:off x="6819900" y="4470797"/>
+            <a:ext cx="1483765" cy="355600"/>
           </a:xfrm>
           <a:prstGeom prst="rect">
             <a:avLst/>
@@ -13266,10 +13169,13 @@
           <a:ln/>
         </p:spPr>
         <p:txBody>
-          <a:bodyPr wrap="none" lIns="0" tIns="0" rIns="0" bIns="0" rtlCol="0" anchor="ctr"/>
-          <a:lstStyle/>
-          <a:p>
-            <a:pPr algn="l" indent="0" marL="0">
+          <a:bodyPr wrap="none" lIns="0" tIns="0" rIns="0" bIns="0" rtlCol="0" anchor="t"/>
+          <a:lstStyle/>
+          <a:p>
+            <a:pPr algn="l" indent="0" marL="0">
+              <a:lnSpc>
+                <a:spcPts val="1400"/>
+              </a:lnSpc>
               <a:buNone/>
             </a:pPr>
             <a:r>
@@ -13285,30 +13191,11 @@
             </a:r>
             <a:endParaRPr lang="en-US" sz="950" dirty="0"/>
           </a:p>
-        </p:txBody>
-      </p:sp>
-      <p:sp>
-        <p:nvSpPr>
-          <p:cNvPr id="82" name="픽셀 → 실제 길이 환산"/>
-          <p:cNvSpPr txBox="1"/>
-          <p:nvPr/>
-        </p:nvSpPr>
-        <p:spPr>
-          <a:xfrm>
-            <a:off x="6819900" y="4680347"/>
-            <a:ext cx="1072017" cy="146050"/>
-          </a:xfrm>
-          <a:prstGeom prst="rect">
-            <a:avLst/>
-          </a:prstGeom>
-          <a:noFill/>
-          <a:ln/>
-        </p:spPr>
-        <p:txBody>
-          <a:bodyPr wrap="none" lIns="0" tIns="0" rIns="0" bIns="0" rtlCol="0" anchor="ctr"/>
-          <a:lstStyle/>
-          <a:p>
-            <a:pPr algn="l" indent="0" marL="0">
+          <a:p>
+            <a:pPr algn="l" indent="0" marL="0">
+              <a:lnSpc>
+                <a:spcPts val="1400"/>
+              </a:lnSpc>
               <a:buNone/>
             </a:pPr>
             <a:r>
@@ -13323,6 +13210,9 @@
               <a:t>픽셀 → 실제 길이</a:t>
             </a:r>
             <a:pPr algn="l" indent="0" marL="0">
+              <a:lnSpc>
+                <a:spcPts val="1400"/>
+              </a:lnSpc>
               <a:buNone/>
             </a:pPr>
             <a:r>
@@ -13342,7 +13232,7 @@
       </p:sp>
       <p:sp>
         <p:nvSpPr>
-          <p:cNvPr id="83" name="1 px = 33.88 mm"/>
+          <p:cNvPr id="79" name="1 px = 33.88 mm"/>
           <p:cNvSpPr txBox="1"/>
           <p:nvPr/>
         </p:nvSpPr>
@@ -13381,7 +13271,7 @@
       </p:sp>
       <p:sp>
         <p:nvSpPr>
-          <p:cNvPr id="84" name="예시"/>
+          <p:cNvPr id="80" name="예시"/>
           <p:cNvSpPr txBox="1"/>
           <p:nvPr/>
         </p:nvSpPr>
@@ -13420,7 +13310,7 @@
       </p:sp>
       <p:sp>
         <p:nvSpPr>
-          <p:cNvPr id="85" name="매칭"/>
+          <p:cNvPr id="81" name="매칭"/>
           <p:cNvSpPr txBox="1"/>
           <p:nvPr/>
         </p:nvSpPr>
@@ -13459,7 +13349,7 @@
       </p:sp>
       <p:sp>
         <p:nvSpPr>
-          <p:cNvPr id="86" name="X·Y + Z → 3차원 위치 확정"/>
+          <p:cNvPr id="82" name="X·Y + Z → 3차원 위치 확정"/>
           <p:cNvSpPr txBox="1"/>
           <p:nvPr/>
         </p:nvSpPr>
@@ -13512,7 +13402,7 @@
       </p:sp>
       <p:sp>
         <p:nvSpPr>
-          <p:cNvPr id="87" name="핵심 기법"/>
+          <p:cNvPr id="83" name="핵심 기법"/>
           <p:cNvSpPr txBox="1"/>
           <p:nvPr/>
         </p:nvSpPr>
@@ -13551,7 +13441,7 @@
       </p:sp>
       <p:sp>
         <p:nvSpPr>
-          <p:cNvPr id="88" name="LMM 기반 축척 보정"/>
+          <p:cNvPr id="84" name="LMM 기반 축척 보정"/>
           <p:cNvSpPr txBox="1"/>
           <p:nvPr/>
         </p:nvSpPr>
@@ -13590,7 +13480,7 @@
       </p:sp>
       <p:sp>
         <p:nvSpPr>
-          <p:cNvPr id="89" name="헝가리안 알고리즘"/>
+          <p:cNvPr id="85" name="헝가리안 알고리즘"/>
           <p:cNvSpPr txBox="1"/>
           <p:nvPr/>
         </p:nvSpPr>
@@ -13629,7 +13519,7 @@
       </p:sp>
       <p:sp>
         <p:nvSpPr>
-          <p:cNvPr id="90" name="(최적 1:1 매칭)"/>
+          <p:cNvPr id="86" name="(최적 1:1 매칭)"/>
           <p:cNvSpPr txBox="1"/>
           <p:nvPr/>
         </p:nvSpPr>
@@ -13668,7 +13558,7 @@
       </p:sp>
       <p:sp>
         <p:nvSpPr>
-          <p:cNvPr id="91" name="STEP 4"/>
+          <p:cNvPr id="87" name="STEP 4"/>
           <p:cNvSpPr txBox="1"/>
           <p:nvPr/>
         </p:nvSpPr>
@@ -13707,7 +13597,7 @@
       </p:sp>
       <p:sp>
         <p:nvSpPr>
-          <p:cNvPr id="92" name="BIM 자동 생성"/>
+          <p:cNvPr id="88" name="BIM 자동 생성"/>
           <p:cNvSpPr txBox="1"/>
           <p:nvPr/>
         </p:nvSpPr>
@@ -13746,7 +13636,7 @@
       </p:sp>
       <p:sp>
         <p:nvSpPr>
-          <p:cNvPr id="93" name="높이까지 갖춘 3D BIM 모델"/>
+          <p:cNvPr id="89" name="높이까지 갖춘 3D BIM 모델"/>
           <p:cNvSpPr txBox="1"/>
           <p:nvPr/>
         </p:nvSpPr>
@@ -13785,7 +13675,7 @@
       </p:sp>
       <p:sp>
         <p:nvSpPr>
-          <p:cNvPr id="94" name="벽체"/>
+          <p:cNvPr id="90" name="벽체"/>
           <p:cNvSpPr txBox="1"/>
           <p:nvPr/>
         </p:nvSpPr>
@@ -13824,14 +13714,14 @@
       </p:sp>
       <p:sp>
         <p:nvSpPr>
-          <p:cNvPr id="95" name="골격선(스켈레톤)으로"/>
+          <p:cNvPr id="91" name="골격선(스켈레톤)으로벽 중심선 추출"/>
           <p:cNvSpPr txBox="1"/>
           <p:nvPr/>
         </p:nvSpPr>
         <p:spPr>
           <a:xfrm>
-            <a:off x="9639300" y="4502547"/>
-            <a:ext cx="1044041" cy="146050"/>
+            <a:off x="9639300" y="4470797"/>
+            <a:ext cx="1044041" cy="355600"/>
           </a:xfrm>
           <a:prstGeom prst="rect">
             <a:avLst/>
@@ -13840,10 +13730,13 @@
           <a:ln/>
         </p:spPr>
         <p:txBody>
-          <a:bodyPr wrap="none" lIns="0" tIns="0" rIns="0" bIns="0" rtlCol="0" anchor="ctr"/>
-          <a:lstStyle/>
-          <a:p>
-            <a:pPr algn="l" indent="0" marL="0">
+          <a:bodyPr wrap="none" lIns="0" tIns="0" rIns="0" bIns="0" rtlCol="0" anchor="t"/>
+          <a:lstStyle/>
+          <a:p>
+            <a:pPr algn="l" indent="0" marL="0">
+              <a:lnSpc>
+                <a:spcPts val="1400"/>
+              </a:lnSpc>
               <a:buNone/>
             </a:pPr>
             <a:r>
@@ -13859,30 +13752,11 @@
             </a:r>
             <a:endParaRPr lang="en-US" sz="950" dirty="0"/>
           </a:p>
-        </p:txBody>
-      </p:sp>
-      <p:sp>
-        <p:nvSpPr>
-          <p:cNvPr id="96" name="벽 중심선 추출"/>
-          <p:cNvSpPr txBox="1"/>
-          <p:nvPr/>
-        </p:nvSpPr>
-        <p:spPr>
-          <a:xfrm>
-            <a:off x="9639300" y="4680347"/>
-            <a:ext cx="703163" cy="146050"/>
-          </a:xfrm>
-          <a:prstGeom prst="rect">
-            <a:avLst/>
-          </a:prstGeom>
-          <a:noFill/>
-          <a:ln/>
-        </p:spPr>
-        <p:txBody>
-          <a:bodyPr wrap="none" lIns="0" tIns="0" rIns="0" bIns="0" rtlCol="0" anchor="ctr"/>
-          <a:lstStyle/>
-          <a:p>
-            <a:pPr algn="l" indent="0" marL="0">
+          <a:p>
+            <a:pPr algn="l" indent="0" marL="0">
+              <a:lnSpc>
+                <a:spcPts val="1400"/>
+              </a:lnSpc>
               <a:buNone/>
             </a:pPr>
             <a:r>
@@ -13902,7 +13776,7 @@
       </p:sp>
       <p:sp>
         <p:nvSpPr>
-          <p:cNvPr id="97" name="창·문"/>
+          <p:cNvPr id="92" name="창·문"/>
           <p:cNvSpPr txBox="1"/>
           <p:nvPr/>
         </p:nvSpPr>
@@ -13941,14 +13815,14 @@
       </p:sp>
       <p:sp>
         <p:nvSpPr>
-          <p:cNvPr id="98" name="붙일 벽 결정(호스팅) 후"/>
+          <p:cNvPr id="93" name="붙일 벽 결정(호스팅) 후Revit API로 BIM 생성"/>
           <p:cNvSpPr txBox="1"/>
           <p:nvPr/>
         </p:nvSpPr>
         <p:spPr>
           <a:xfrm>
-            <a:off x="9639300" y="4908947"/>
-            <a:ext cx="1126180" cy="146050"/>
+            <a:off x="9639300" y="4877197"/>
+            <a:ext cx="1126180" cy="355600"/>
           </a:xfrm>
           <a:prstGeom prst="rect">
             <a:avLst/>
@@ -13957,10 +13831,13 @@
           <a:ln/>
         </p:spPr>
         <p:txBody>
-          <a:bodyPr wrap="none" lIns="0" tIns="0" rIns="0" bIns="0" rtlCol="0" anchor="ctr"/>
-          <a:lstStyle/>
-          <a:p>
-            <a:pPr algn="l" indent="0" marL="0">
+          <a:bodyPr wrap="none" lIns="0" tIns="0" rIns="0" bIns="0" rtlCol="0" anchor="t"/>
+          <a:lstStyle/>
+          <a:p>
+            <a:pPr algn="l" indent="0" marL="0">
+              <a:lnSpc>
+                <a:spcPts val="1400"/>
+              </a:lnSpc>
               <a:buNone/>
             </a:pPr>
             <a:r>
@@ -13976,30 +13853,11 @@
             </a:r>
             <a:endParaRPr lang="en-US" sz="950" dirty="0"/>
           </a:p>
-        </p:txBody>
-      </p:sp>
-      <p:sp>
-        <p:nvSpPr>
-          <p:cNvPr id="99" name="Revit API로 BIM 생성"/>
-          <p:cNvSpPr txBox="1"/>
-          <p:nvPr/>
-        </p:nvSpPr>
-        <p:spPr>
-          <a:xfrm>
-            <a:off x="9639300" y="5086747"/>
-            <a:ext cx="1092000" cy="146050"/>
-          </a:xfrm>
-          <a:prstGeom prst="rect">
-            <a:avLst/>
-          </a:prstGeom>
-          <a:noFill/>
-          <a:ln/>
-        </p:spPr>
-        <p:txBody>
-          <a:bodyPr wrap="none" lIns="0" tIns="0" rIns="0" bIns="0" rtlCol="0" anchor="ctr"/>
-          <a:lstStyle/>
-          <a:p>
-            <a:pPr algn="l" indent="0" marL="0">
+          <a:p>
+            <a:pPr algn="l" indent="0" marL="0">
+              <a:lnSpc>
+                <a:spcPts val="1400"/>
+              </a:lnSpc>
               <a:buNone/>
             </a:pPr>
             <a:r>
@@ -14019,7 +13877,7 @@
       </p:sp>
       <p:sp>
         <p:nvSpPr>
-          <p:cNvPr id="100" name="핵심 기법"/>
+          <p:cNvPr id="94" name="핵심 기법"/>
           <p:cNvSpPr txBox="1"/>
           <p:nvPr/>
         </p:nvSpPr>
@@ -14058,7 +13916,7 @@
       </p:sp>
       <p:sp>
         <p:nvSpPr>
-          <p:cNvPr id="101" name="스켈레톤 기반 벽체 추출"/>
+          <p:cNvPr id="95" name="스켈레톤 기반 벽체 추출"/>
           <p:cNvSpPr txBox="1"/>
           <p:nvPr/>
         </p:nvSpPr>
@@ -14097,7 +13955,7 @@
       </p:sp>
       <p:sp>
         <p:nvSpPr>
-          <p:cNvPr id="102" name="Revit API"/>
+          <p:cNvPr id="96" name="Revit API"/>
           <p:cNvSpPr txBox="1"/>
           <p:nvPr/>
         </p:nvSpPr>
@@ -14136,7 +13994,7 @@
       </p:sp>
       <p:sp>
         <p:nvSpPr>
-          <p:cNvPr id="103" name="석사 연구 발표  ·  평면도와 입면도 객체 인식 및 정보 통합을 통한 "/>
+          <p:cNvPr id="97" name="석사 연구 발표  ·  평면도와 입면도 객체 인식 및 정보 통합을 통한 "/>
           <p:cNvSpPr txBox="1"/>
           <p:nvPr/>
         </p:nvSpPr>
@@ -14175,7 +14033,7 @@
       </p:sp>
       <p:sp>
         <p:nvSpPr>
-          <p:cNvPr id="104" name="03 / 05"/>
+          <p:cNvPr id="98" name="03 / 05"/>
           <p:cNvSpPr txBox="1"/>
           <p:nvPr/>
         </p:nvSpPr>
@@ -17991,14 +17849,14 @@
       </p:sp>
       <p:sp>
         <p:nvSpPr>
-          <p:cNvPr id="93" name="도면 종류별 최적"/>
+          <p:cNvPr id="93" name="도면 종류별 최적학습·인식 전략 제안"/>
           <p:cNvSpPr txBox="1"/>
           <p:nvPr/>
         </p:nvSpPr>
         <p:spPr>
           <a:xfrm>
-            <a:off x="1473200" y="2204442"/>
-            <a:ext cx="1074120" cy="196850"/>
+            <a:off x="1473200" y="2173486"/>
+            <a:ext cx="1262378" cy="455612"/>
           </a:xfrm>
           <a:prstGeom prst="rect">
             <a:avLst/>
@@ -18007,10 +17865,13 @@
           <a:ln/>
         </p:spPr>
         <p:txBody>
-          <a:bodyPr wrap="none" lIns="0" tIns="0" rIns="0" bIns="0" rtlCol="0" anchor="ctr"/>
-          <a:lstStyle/>
-          <a:p>
-            <a:pPr algn="l" indent="0" marL="0">
+          <a:bodyPr wrap="none" lIns="0" tIns="0" rIns="0" bIns="0" rtlCol="0" anchor="t"/>
+          <a:lstStyle/>
+          <a:p>
+            <a:pPr algn="l" indent="0" marL="0">
+              <a:lnSpc>
+                <a:spcPts val="1794"/>
+              </a:lnSpc>
               <a:buNone/>
             </a:pPr>
             <a:r>
@@ -18026,30 +17887,11 @@
             </a:r>
             <a:endParaRPr lang="en-US" sz="1300" dirty="0"/>
           </a:p>
-        </p:txBody>
-      </p:sp>
-      <p:sp>
-        <p:nvSpPr>
-          <p:cNvPr id="94" name="학습·인식 전략 제안"/>
-          <p:cNvSpPr txBox="1"/>
-          <p:nvPr/>
-        </p:nvSpPr>
-        <p:spPr>
-          <a:xfrm>
-            <a:off x="1473200" y="2432248"/>
-            <a:ext cx="1262378" cy="196850"/>
-          </a:xfrm>
-          <a:prstGeom prst="rect">
-            <a:avLst/>
-          </a:prstGeom>
-          <a:noFill/>
-          <a:ln/>
-        </p:spPr>
-        <p:txBody>
-          <a:bodyPr wrap="none" lIns="0" tIns="0" rIns="0" bIns="0" rtlCol="0" anchor="ctr"/>
-          <a:lstStyle/>
-          <a:p>
-            <a:pPr algn="l" indent="0" marL="0">
+          <a:p>
+            <a:pPr algn="l" indent="0" marL="0">
+              <a:lnSpc>
+                <a:spcPts val="1794"/>
+              </a:lnSpc>
               <a:buNone/>
             </a:pPr>
             <a:r>
@@ -18069,7 +17911,7 @@
       </p:sp>
       <p:sp>
         <p:nvSpPr>
-          <p:cNvPr id="95" name="도면 객체 인식 mAP@0.5"/>
+          <p:cNvPr id="94" name="도면 객체 인식 mAP@0.5"/>
           <p:cNvSpPr txBox="1"/>
           <p:nvPr/>
         </p:nvSpPr>
@@ -18108,7 +17950,7 @@
       </p:sp>
       <p:sp>
         <p:nvSpPr>
-          <p:cNvPr id="96" name="·  학습 이미지 평면도 72,792장 · 입면도 16,992장"/>
+          <p:cNvPr id="95" name="·  학습 이미지 평면도 72,792장 · 입면도 16,992장"/>
           <p:cNvSpPr txBox="1"/>
           <p:nvPr/>
         </p:nvSpPr>
@@ -18147,7 +17989,7 @@
       </p:sp>
       <p:sp>
         <p:nvSpPr>
-          <p:cNvPr id="97" name="평면도"/>
+          <p:cNvPr id="96" name="평면도"/>
           <p:cNvSpPr txBox="1"/>
           <p:nvPr/>
         </p:nvSpPr>
@@ -18186,7 +18028,7 @@
       </p:sp>
       <p:sp>
         <p:nvSpPr>
-          <p:cNvPr id="98" name="Baseline 0.507"/>
+          <p:cNvPr id="97" name="Baseline 0.507"/>
           <p:cNvSpPr txBox="1"/>
           <p:nvPr/>
         </p:nvSpPr>
@@ -18239,7 +18081,7 @@
       </p:sp>
       <p:sp>
         <p:nvSpPr>
-          <p:cNvPr id="99" name="0.934"/>
+          <p:cNvPr id="98" name="0.934"/>
           <p:cNvSpPr txBox="1"/>
           <p:nvPr/>
         </p:nvSpPr>
@@ -18278,7 +18120,7 @@
       </p:sp>
       <p:sp>
         <p:nvSpPr>
-          <p:cNvPr id="100" name="+42.7%p"/>
+          <p:cNvPr id="99" name="+42.7%p"/>
           <p:cNvSpPr txBox="1"/>
           <p:nvPr/>
         </p:nvSpPr>
@@ -18317,7 +18159,7 @@
       </p:sp>
       <p:sp>
         <p:nvSpPr>
-          <p:cNvPr id="101" name="입면도"/>
+          <p:cNvPr id="100" name="입면도"/>
           <p:cNvSpPr txBox="1"/>
           <p:nvPr/>
         </p:nvSpPr>
@@ -18356,7 +18198,7 @@
       </p:sp>
       <p:sp>
         <p:nvSpPr>
-          <p:cNvPr id="102" name="Baseline 0.355"/>
+          <p:cNvPr id="101" name="Baseline 0.355"/>
           <p:cNvSpPr txBox="1"/>
           <p:nvPr/>
         </p:nvSpPr>
@@ -18409,7 +18251,7 @@
       </p:sp>
       <p:sp>
         <p:nvSpPr>
-          <p:cNvPr id="103" name="0.838"/>
+          <p:cNvPr id="102" name="0.838"/>
           <p:cNvSpPr txBox="1"/>
           <p:nvPr/>
         </p:nvSpPr>
@@ -18448,7 +18290,7 @@
       </p:sp>
       <p:sp>
         <p:nvSpPr>
-          <p:cNvPr id="104" name="+48.3%p"/>
+          <p:cNvPr id="103" name="+48.3%p"/>
           <p:cNvSpPr txBox="1"/>
           <p:nvPr/>
         </p:nvSpPr>
@@ -18487,7 +18329,7 @@
       </p:sp>
       <p:sp>
         <p:nvSpPr>
-          <p:cNvPr id="105" name="기여 2"/>
+          <p:cNvPr id="104" name="기여 2"/>
           <p:cNvSpPr txBox="1"/>
           <p:nvPr/>
         </p:nvSpPr>
@@ -18526,14 +18368,14 @@
       </p:sp>
       <p:sp>
         <p:nvSpPr>
-          <p:cNvPr id="106" name="CAD 정보 없이 평면도·입면도 간"/>
+          <p:cNvPr id="105" name="CAD 정보 없이 평면도·입면도 간객체 대응 관계 정의"/>
           <p:cNvSpPr txBox="1"/>
           <p:nvPr/>
         </p:nvSpPr>
         <p:spPr>
           <a:xfrm>
-            <a:off x="1473200" y="3728442"/>
-            <a:ext cx="2117425" cy="196850"/>
+            <a:off x="1473200" y="3697486"/>
+            <a:ext cx="2117425" cy="455612"/>
           </a:xfrm>
           <a:prstGeom prst="rect">
             <a:avLst/>
@@ -18542,10 +18384,13 @@
           <a:ln/>
         </p:spPr>
         <p:txBody>
-          <a:bodyPr wrap="none" lIns="0" tIns="0" rIns="0" bIns="0" rtlCol="0" anchor="ctr"/>
-          <a:lstStyle/>
-          <a:p>
-            <a:pPr algn="l" indent="0" marL="0">
+          <a:bodyPr wrap="none" lIns="0" tIns="0" rIns="0" bIns="0" rtlCol="0" anchor="t"/>
+          <a:lstStyle/>
+          <a:p>
+            <a:pPr algn="l" indent="0" marL="0">
+              <a:lnSpc>
+                <a:spcPts val="1794"/>
+              </a:lnSpc>
               <a:buNone/>
             </a:pPr>
             <a:r>
@@ -18561,30 +18406,11 @@
             </a:r>
             <a:endParaRPr lang="en-US" sz="1300" dirty="0"/>
           </a:p>
-        </p:txBody>
-      </p:sp>
-      <p:sp>
-        <p:nvSpPr>
-          <p:cNvPr id="107" name="객체 대응 관계 정의"/>
-          <p:cNvSpPr txBox="1"/>
-          <p:nvPr/>
-        </p:nvSpPr>
-        <p:spPr>
-          <a:xfrm>
-            <a:off x="1473200" y="3956248"/>
-            <a:ext cx="1250494" cy="196850"/>
-          </a:xfrm>
-          <a:prstGeom prst="rect">
-            <a:avLst/>
-          </a:prstGeom>
-          <a:noFill/>
-          <a:ln/>
-        </p:spPr>
-        <p:txBody>
-          <a:bodyPr wrap="none" lIns="0" tIns="0" rIns="0" bIns="0" rtlCol="0" anchor="ctr"/>
-          <a:lstStyle/>
-          <a:p>
-            <a:pPr algn="l" indent="0" marL="0">
+          <a:p>
+            <a:pPr algn="l" indent="0" marL="0">
+              <a:lnSpc>
+                <a:spcPts val="1794"/>
+              </a:lnSpc>
               <a:buNone/>
             </a:pPr>
             <a:r>
@@ -18604,7 +18430,7 @@
       </p:sp>
       <p:sp>
         <p:nvSpPr>
-          <p:cNvPr id="108" name="대응 객체 매칭 F1-score"/>
+          <p:cNvPr id="106" name="대응 객체 매칭 F1-score"/>
           <p:cNvSpPr txBox="1"/>
           <p:nvPr/>
         </p:nvSpPr>
@@ -18643,7 +18469,7 @@
       </p:sp>
       <p:sp>
         <p:nvSpPr>
-          <p:cNvPr id="109" name="·  8개 동 BIM, 개구부 3,458개"/>
+          <p:cNvPr id="107" name="·  8개 동 BIM, 개구부 3,458개"/>
           <p:cNvSpPr txBox="1"/>
           <p:nvPr/>
         </p:nvSpPr>
@@ -18682,7 +18508,7 @@
       </p:sp>
       <p:sp>
         <p:nvSpPr>
-          <p:cNvPr id="110" name="창문"/>
+          <p:cNvPr id="108" name="창문"/>
           <p:cNvSpPr txBox="1"/>
           <p:nvPr/>
         </p:nvSpPr>
@@ -18721,7 +18547,7 @@
       </p:sp>
       <p:sp>
         <p:nvSpPr>
-          <p:cNvPr id="111" name="3,410개"/>
+          <p:cNvPr id="109" name="3,410개"/>
           <p:cNvSpPr txBox="1"/>
           <p:nvPr/>
         </p:nvSpPr>
@@ -18774,7 +18600,7 @@
       </p:sp>
       <p:sp>
         <p:nvSpPr>
-          <p:cNvPr id="112" name="0.93"/>
+          <p:cNvPr id="110" name="0.93"/>
           <p:cNvSpPr txBox="1"/>
           <p:nvPr/>
         </p:nvSpPr>
@@ -18813,7 +18639,7 @@
       </p:sp>
       <p:sp>
         <p:nvSpPr>
-          <p:cNvPr id="113" name="문"/>
+          <p:cNvPr id="111" name="문"/>
           <p:cNvSpPr txBox="1"/>
           <p:nvPr/>
         </p:nvSpPr>
@@ -18852,7 +18678,7 @@
       </p:sp>
       <p:sp>
         <p:nvSpPr>
-          <p:cNvPr id="114" name="48개"/>
+          <p:cNvPr id="112" name="48개"/>
           <p:cNvSpPr txBox="1"/>
           <p:nvPr/>
         </p:nvSpPr>
@@ -18905,7 +18731,7 @@
       </p:sp>
       <p:sp>
         <p:nvSpPr>
-          <p:cNvPr id="115" name="0.95"/>
+          <p:cNvPr id="113" name="0.95"/>
           <p:cNvSpPr txBox="1"/>
           <p:nvPr/>
         </p:nvSpPr>
@@ -18944,7 +18770,7 @@
       </p:sp>
       <p:sp>
         <p:nvSpPr>
-          <p:cNvPr id="116" name="기여 3"/>
+          <p:cNvPr id="114" name="기여 3"/>
           <p:cNvSpPr txBox="1"/>
           <p:nvPr/>
         </p:nvSpPr>
@@ -18983,14 +18809,14 @@
       </p:sp>
       <p:sp>
         <p:nvSpPr>
-          <p:cNvPr id="117" name="LMM 기반 축척 인식으로 불완전한"/>
+          <p:cNvPr id="115" name="LMM 기반 축척 인식으로 불완전한도면에서도 안정적인 치수 보정"/>
           <p:cNvSpPr txBox="1"/>
           <p:nvPr/>
         </p:nvSpPr>
         <p:spPr>
           <a:xfrm>
-            <a:off x="1473200" y="5252442"/>
-            <a:ext cx="2247207" cy="196850"/>
+            <a:off x="1473200" y="5221486"/>
+            <a:ext cx="2247207" cy="455612"/>
           </a:xfrm>
           <a:prstGeom prst="rect">
             <a:avLst/>
@@ -18999,10 +18825,13 @@
           <a:ln/>
         </p:spPr>
         <p:txBody>
-          <a:bodyPr wrap="none" lIns="0" tIns="0" rIns="0" bIns="0" rtlCol="0" anchor="ctr"/>
-          <a:lstStyle/>
-          <a:p>
-            <a:pPr algn="l" indent="0" marL="0">
+          <a:bodyPr wrap="none" lIns="0" tIns="0" rIns="0" bIns="0" rtlCol="0" anchor="t"/>
+          <a:lstStyle/>
+          <a:p>
+            <a:pPr algn="l" indent="0" marL="0">
+              <a:lnSpc>
+                <a:spcPts val="1794"/>
+              </a:lnSpc>
               <a:buNone/>
             </a:pPr>
             <a:r>
@@ -19018,30 +18847,11 @@
             </a:r>
             <a:endParaRPr lang="en-US" sz="1300" dirty="0"/>
           </a:p>
-        </p:txBody>
-      </p:sp>
-      <p:sp>
-        <p:nvSpPr>
-          <p:cNvPr id="118" name="도면에서도 안정적인 치수 보정"/>
-          <p:cNvSpPr txBox="1"/>
-          <p:nvPr/>
-        </p:nvSpPr>
-        <p:spPr>
-          <a:xfrm>
-            <a:off x="1473200" y="5480248"/>
-            <a:ext cx="1971762" cy="196850"/>
-          </a:xfrm>
-          <a:prstGeom prst="rect">
-            <a:avLst/>
-          </a:prstGeom>
-          <a:noFill/>
-          <a:ln/>
-        </p:spPr>
-        <p:txBody>
-          <a:bodyPr wrap="none" lIns="0" tIns="0" rIns="0" bIns="0" rtlCol="0" anchor="ctr"/>
-          <a:lstStyle/>
-          <a:p>
-            <a:pPr algn="l" indent="0" marL="0">
+          <a:p>
+            <a:pPr algn="l" indent="0" marL="0">
+              <a:lnSpc>
+                <a:spcPts val="1794"/>
+              </a:lnSpc>
               <a:buNone/>
             </a:pPr>
             <a:r>
@@ -19061,7 +18871,7 @@
       </p:sp>
       <p:sp>
         <p:nvSpPr>
-          <p:cNvPr id="119" name="축척 인식 정확도"/>
+          <p:cNvPr id="116" name="축척 인식 정확도"/>
           <p:cNvSpPr txBox="1"/>
           <p:nvPr/>
         </p:nvSpPr>
@@ -19100,7 +18910,7 @@
       </p:sp>
       <p:sp>
         <p:nvSpPr>
-          <p:cNvPr id="120" name="·  Tesseract OCR 대비"/>
+          <p:cNvPr id="117" name="·  Tesseract OCR 대비"/>
           <p:cNvSpPr txBox="1"/>
           <p:nvPr/>
         </p:nvSpPr>
@@ -19139,7 +18949,7 @@
       </p:sp>
       <p:sp>
         <p:nvSpPr>
-          <p:cNvPr id="121" name="LMM(GPT-4o)"/>
+          <p:cNvPr id="118" name="LMM(GPT-4o)"/>
           <p:cNvSpPr txBox="1"/>
           <p:nvPr/>
         </p:nvSpPr>
@@ -19178,7 +18988,7 @@
       </p:sp>
       <p:sp>
         <p:nvSpPr>
-          <p:cNvPr id="122" name="0.707"/>
+          <p:cNvPr id="119" name="0.707"/>
           <p:cNvSpPr txBox="1"/>
           <p:nvPr/>
         </p:nvSpPr>
@@ -19217,7 +19027,7 @@
       </p:sp>
       <p:sp>
         <p:nvSpPr>
-          <p:cNvPr id="123" name="+33.8%p"/>
+          <p:cNvPr id="120" name="+33.8%p"/>
           <p:cNvSpPr txBox="1"/>
           <p:nvPr/>
         </p:nvSpPr>
@@ -19256,7 +19066,7 @@
       </p:sp>
       <p:sp>
         <p:nvSpPr>
-          <p:cNvPr id="124" name="Tesseract OCR"/>
+          <p:cNvPr id="121" name="Tesseract OCR"/>
           <p:cNvSpPr txBox="1"/>
           <p:nvPr/>
         </p:nvSpPr>
@@ -19295,7 +19105,7 @@
       </p:sp>
       <p:sp>
         <p:nvSpPr>
-          <p:cNvPr id="125" name="0.369"/>
+          <p:cNvPr id="122" name="0.369"/>
           <p:cNvSpPr txBox="1"/>
           <p:nvPr/>
         </p:nvSpPr>
@@ -19334,7 +19144,7 @@
       </p:sp>
       <p:sp>
         <p:nvSpPr>
-          <p:cNvPr id="126" name="mAP@0.5 객체를 맞게 찾아낸 정도  ·  F1-score 정밀도·재"/>
+          <p:cNvPr id="123" name="mAP@0.5 객체를 맞게 찾아낸 정도  ·  F1-score 정밀도·재"/>
           <p:cNvSpPr txBox="1"/>
           <p:nvPr/>
         </p:nvSpPr>
@@ -19443,7 +19253,7 @@
       </p:sp>
       <p:sp>
         <p:nvSpPr>
-          <p:cNvPr id="127" name="최종 결과"/>
+          <p:cNvPr id="124" name="최종 결과"/>
           <p:cNvSpPr txBox="1"/>
           <p:nvPr/>
         </p:nvSpPr>
@@ -19482,7 +19292,7 @@
       </p:sp>
       <p:sp>
         <p:nvSpPr>
-          <p:cNvPr id="128" name="최종 BIM 생성"/>
+          <p:cNvPr id="125" name="최종 BIM 생성"/>
           <p:cNvSpPr txBox="1"/>
           <p:nvPr/>
         </p:nvSpPr>
@@ -19521,7 +19331,7 @@
       </p:sp>
       <p:sp>
         <p:nvSpPr>
-          <p:cNvPr id="129" name="건물 1동 실증"/>
+          <p:cNvPr id="126" name="건물 1동 실증"/>
           <p:cNvSpPr txBox="1"/>
           <p:nvPr/>
         </p:nvSpPr>
@@ -19562,7 +19372,7 @@
       </p:sp>
       <p:sp>
         <p:nvSpPr>
-          <p:cNvPr id="130" name="379"/>
+          <p:cNvPr id="127" name="379"/>
           <p:cNvSpPr txBox="1"/>
           <p:nvPr/>
         </p:nvSpPr>
@@ -19601,7 +19411,7 @@
       </p:sp>
       <p:sp>
         <p:nvSpPr>
-          <p:cNvPr id="131" name="/ 406"/>
+          <p:cNvPr id="128" name="/ 406"/>
           <p:cNvSpPr txBox="1"/>
           <p:nvPr/>
         </p:nvSpPr>
@@ -19642,7 +19452,7 @@
       </p:sp>
       <p:sp>
         <p:nvSpPr>
-          <p:cNvPr id="132" name="406개 객체 중 379개 자동 생성"/>
+          <p:cNvPr id="129" name="406개 객체 중 379개 자동 생성"/>
           <p:cNvSpPr txBox="1"/>
           <p:nvPr/>
         </p:nvSpPr>
@@ -19683,7 +19493,7 @@
       </p:sp>
       <p:sp>
         <p:nvSpPr>
-          <p:cNvPr id="133" name="생성 완성도"/>
+          <p:cNvPr id="130" name="생성 완성도"/>
           <p:cNvSpPr txBox="1"/>
           <p:nvPr/>
         </p:nvSpPr>
@@ -19724,7 +19534,7 @@
       </p:sp>
       <p:sp>
         <p:nvSpPr>
-          <p:cNvPr id="134" name="93.3%"/>
+          <p:cNvPr id="131" name="93.3%"/>
           <p:cNvSpPr txBox="1"/>
           <p:nvPr/>
         </p:nvSpPr>
@@ -19763,7 +19573,7 @@
       </p:sp>
       <p:sp>
         <p:nvSpPr>
-          <p:cNvPr id="135" name="요소별 생성"/>
+          <p:cNvPr id="132" name="요소별 생성"/>
           <p:cNvSpPr txBox="1"/>
           <p:nvPr/>
         </p:nvSpPr>
@@ -19804,7 +19614,7 @@
       </p:sp>
       <p:sp>
         <p:nvSpPr>
-          <p:cNvPr id="136" name="벽"/>
+          <p:cNvPr id="133" name="벽"/>
           <p:cNvSpPr txBox="1"/>
           <p:nvPr/>
         </p:nvSpPr>
@@ -19845,7 +19655,7 @@
       </p:sp>
       <p:sp>
         <p:nvSpPr>
-          <p:cNvPr id="137" name="135 / 153"/>
+          <p:cNvPr id="134" name="135 / 153"/>
           <p:cNvSpPr txBox="1"/>
           <p:nvPr/>
         </p:nvSpPr>
@@ -19900,7 +19710,7 @@
       </p:sp>
       <p:sp>
         <p:nvSpPr>
-          <p:cNvPr id="138" name="문"/>
+          <p:cNvPr id="135" name="문"/>
           <p:cNvSpPr txBox="1"/>
           <p:nvPr/>
         </p:nvSpPr>
@@ -19941,7 +19751,7 @@
       </p:sp>
       <p:sp>
         <p:nvSpPr>
-          <p:cNvPr id="139" name="64 / 64"/>
+          <p:cNvPr id="136" name="64 / 64"/>
           <p:cNvSpPr txBox="1"/>
           <p:nvPr/>
         </p:nvSpPr>
@@ -19996,7 +19806,7 @@
       </p:sp>
       <p:sp>
         <p:nvSpPr>
-          <p:cNvPr id="140" name="창문"/>
+          <p:cNvPr id="137" name="창문"/>
           <p:cNvSpPr txBox="1"/>
           <p:nvPr/>
         </p:nvSpPr>
@@ -20037,7 +19847,7 @@
       </p:sp>
       <p:sp>
         <p:nvSpPr>
-          <p:cNvPr id="141" name="180 / 189"/>
+          <p:cNvPr id="138" name="180 / 189"/>
           <p:cNvSpPr txBox="1"/>
           <p:nvPr/>
         </p:nvSpPr>
@@ -20092,7 +19902,7 @@
       </p:sp>
       <p:sp>
         <p:nvSpPr>
-          <p:cNvPr id="142" name="자동 생성된 3D BIM"/>
+          <p:cNvPr id="139" name="자동 생성된 3D BIM"/>
           <p:cNvSpPr txBox="1"/>
           <p:nvPr/>
         </p:nvSpPr>
@@ -20133,7 +19943,7 @@
       </p:sp>
       <p:sp>
         <p:nvSpPr>
-          <p:cNvPr id="143" name="석사 연구 발표  ·  평면도와 입면도 객체 인식 및 정보 통합을 통한 "/>
+          <p:cNvPr id="140" name="석사 연구 발표  ·  평면도와 입면도 객체 인식 및 정보 통합을 통한 "/>
           <p:cNvSpPr txBox="1"/>
           <p:nvPr/>
         </p:nvSpPr>
@@ -20172,7 +19982,7 @@
       </p:sp>
       <p:sp>
         <p:nvSpPr>
-          <p:cNvPr id="144" name="04 / 05"/>
+          <p:cNvPr id="141" name="04 / 05"/>
           <p:cNvSpPr txBox="1"/>
           <p:nvPr/>
         </p:nvSpPr>
@@ -23235,14 +23045,14 @@
       </p:sp>
       <p:sp>
         <p:nvSpPr>
-          <p:cNvPr id="67" name="직무에서 마주할 세 가지 과제가"/>
+          <p:cNvPr id="67" name="직무에서 마주할 세 가지 과제가제 연구와 맞닿아 있습니다."/>
           <p:cNvSpPr txBox="1"/>
           <p:nvPr/>
         </p:nvSpPr>
         <p:spPr>
           <a:xfrm>
-            <a:off x="609600" y="666750"/>
-            <a:ext cx="3545239" cy="349250"/>
+            <a:off x="609600" y="653852"/>
+            <a:ext cx="3545239" cy="724297"/>
           </a:xfrm>
           <a:prstGeom prst="rect">
             <a:avLst/>
@@ -23251,10 +23061,13 @@
           <a:ln/>
         </p:spPr>
         <p:txBody>
-          <a:bodyPr wrap="none" lIns="0" tIns="0" rIns="0" bIns="0" rtlCol="0" anchor="ctr"/>
-          <a:lstStyle/>
-          <a:p>
-            <a:pPr algn="l" indent="0" marL="0">
+          <a:bodyPr wrap="none" lIns="0" tIns="0" rIns="0" bIns="0" rtlCol="0" anchor="t"/>
+          <a:lstStyle/>
+          <a:p>
+            <a:pPr algn="l" indent="0" marL="0">
+              <a:lnSpc>
+                <a:spcPts val="2852"/>
+              </a:lnSpc>
               <a:buNone/>
             </a:pPr>
             <a:r>
@@ -23270,30 +23083,11 @@
             </a:r>
             <a:endParaRPr lang="en-US" sz="2300" dirty="0"/>
           </a:p>
-        </p:txBody>
-      </p:sp>
-      <p:sp>
-        <p:nvSpPr>
-          <p:cNvPr id="68" name="제 연구와 맞닿아 있습니다."/>
-          <p:cNvSpPr txBox="1"/>
-          <p:nvPr/>
-        </p:nvSpPr>
-        <p:spPr>
-          <a:xfrm>
-            <a:off x="609600" y="1028898"/>
-            <a:ext cx="3055979" cy="349250"/>
-          </a:xfrm>
-          <a:prstGeom prst="rect">
-            <a:avLst/>
-          </a:prstGeom>
-          <a:noFill/>
-          <a:ln/>
-        </p:spPr>
-        <p:txBody>
-          <a:bodyPr wrap="none" lIns="0" tIns="0" rIns="0" bIns="0" rtlCol="0" anchor="ctr"/>
-          <a:lstStyle/>
-          <a:p>
-            <a:pPr algn="l" indent="0" marL="0">
+          <a:p>
+            <a:pPr algn="l" indent="0" marL="0">
+              <a:lnSpc>
+                <a:spcPts val="2852"/>
+              </a:lnSpc>
               <a:buNone/>
             </a:pPr>
             <a:r>
@@ -23308,6 +23102,9 @@
               <a:t>제 연구와 맞닿아</a:t>
             </a:r>
             <a:pPr algn="l" indent="0" marL="0">
+              <a:lnSpc>
+                <a:spcPts val="2852"/>
+              </a:lnSpc>
               <a:buNone/>
             </a:pPr>
             <a:r>
@@ -23327,7 +23124,7 @@
       </p:sp>
       <p:sp>
         <p:nvSpPr>
-          <p:cNvPr id="69" name="01"/>
+          <p:cNvPr id="68" name="01"/>
           <p:cNvSpPr txBox="1"/>
           <p:nvPr/>
         </p:nvSpPr>
@@ -23366,7 +23163,7 @@
       </p:sp>
       <p:sp>
         <p:nvSpPr>
-          <p:cNvPr id="70" name="02"/>
+          <p:cNvPr id="69" name="02"/>
           <p:cNvSpPr txBox="1"/>
           <p:nvPr/>
         </p:nvSpPr>
@@ -23405,7 +23202,7 @@
       </p:sp>
       <p:sp>
         <p:nvSpPr>
-          <p:cNvPr id="71" name="03"/>
+          <p:cNvPr id="70" name="03"/>
           <p:cNvSpPr txBox="1"/>
           <p:nvPr/>
         </p:nvSpPr>
@@ -23444,7 +23241,7 @@
       </p:sp>
       <p:sp>
         <p:nvSpPr>
-          <p:cNvPr id="72" name="04"/>
+          <p:cNvPr id="71" name="04"/>
           <p:cNvSpPr txBox="1"/>
           <p:nvPr/>
         </p:nvSpPr>
@@ -23483,7 +23280,7 @@
       </p:sp>
       <p:sp>
         <p:nvSpPr>
-          <p:cNvPr id="73" name="05"/>
+          <p:cNvPr id="72" name="05"/>
           <p:cNvSpPr txBox="1"/>
           <p:nvPr/>
         </p:nvSpPr>
@@ -23522,7 +23319,7 @@
       </p:sp>
       <p:sp>
         <p:nvSpPr>
-          <p:cNvPr id="74" name="직무 과제"/>
+          <p:cNvPr id="73" name="직무 과제"/>
           <p:cNvSpPr txBox="1"/>
           <p:nvPr/>
         </p:nvSpPr>
@@ -23561,7 +23358,7 @@
       </p:sp>
       <p:sp>
         <p:nvSpPr>
-          <p:cNvPr id="75" name="연구 접점"/>
+          <p:cNvPr id="74" name="연구 접점"/>
           <p:cNvSpPr txBox="1"/>
           <p:nvPr/>
         </p:nvSpPr>
@@ -23600,7 +23397,7 @@
       </p:sp>
       <p:sp>
         <p:nvSpPr>
-          <p:cNvPr id="76" name="과제 1"/>
+          <p:cNvPr id="75" name="과제 1"/>
           <p:cNvSpPr txBox="1"/>
           <p:nvPr/>
         </p:nvSpPr>
@@ -23639,7 +23436,7 @@
       </p:sp>
       <p:sp>
         <p:nvSpPr>
-          <p:cNvPr id="77" name="Virtual FAB 구축"/>
+          <p:cNvPr id="76" name="Virtual FAB 구축"/>
           <p:cNvSpPr txBox="1"/>
           <p:nvPr/>
         </p:nvSpPr>
@@ -23678,14 +23475,14 @@
       </p:sp>
       <p:sp>
         <p:nvSpPr>
-          <p:cNvPr id="78" name="여러 출처의 도면·모델 데이터를"/>
+          <p:cNvPr id="77" name="여러 출처의 도면·모델 데이터를하나로 통합"/>
           <p:cNvSpPr txBox="1"/>
           <p:nvPr/>
         </p:nvSpPr>
         <p:spPr>
           <a:xfrm>
-            <a:off x="3841750" y="2311797"/>
-            <a:ext cx="1748377" cy="165100"/>
+            <a:off x="3841750" y="2267347"/>
+            <a:ext cx="1748377" cy="419100"/>
           </a:xfrm>
           <a:prstGeom prst="rect">
             <a:avLst/>
@@ -23694,10 +23491,13 @@
           <a:ln/>
         </p:spPr>
         <p:txBody>
-          <a:bodyPr wrap="none" lIns="0" tIns="0" rIns="0" bIns="0" rtlCol="0" anchor="ctr"/>
-          <a:lstStyle/>
-          <a:p>
-            <a:pPr algn="l" indent="0" marL="0">
+          <a:bodyPr wrap="none" lIns="0" tIns="0" rIns="0" bIns="0" rtlCol="0" anchor="t"/>
+          <a:lstStyle/>
+          <a:p>
+            <a:pPr algn="l" indent="0" marL="0">
+              <a:lnSpc>
+                <a:spcPts val="1650"/>
+              </a:lnSpc>
               <a:buNone/>
             </a:pPr>
             <a:r>
@@ -23713,30 +23513,11 @@
             </a:r>
             <a:endParaRPr lang="en-US" sz="1100" dirty="0"/>
           </a:p>
-        </p:txBody>
-      </p:sp>
-      <p:sp>
-        <p:nvSpPr>
-          <p:cNvPr id="79" name="하나로 통합"/>
-          <p:cNvSpPr txBox="1"/>
-          <p:nvPr/>
-        </p:nvSpPr>
-        <p:spPr>
-          <a:xfrm>
-            <a:off x="3841750" y="2521347"/>
-            <a:ext cx="667643" cy="165100"/>
-          </a:xfrm>
-          <a:prstGeom prst="rect">
-            <a:avLst/>
-          </a:prstGeom>
-          <a:noFill/>
-          <a:ln/>
-        </p:spPr>
-        <p:txBody>
-          <a:bodyPr wrap="none" lIns="0" tIns="0" rIns="0" bIns="0" rtlCol="0" anchor="ctr"/>
-          <a:lstStyle/>
-          <a:p>
-            <a:pPr algn="l" indent="0" marL="0">
+          <a:p>
+            <a:pPr algn="l" indent="0" marL="0">
+              <a:lnSpc>
+                <a:spcPts val="1650"/>
+              </a:lnSpc>
               <a:buNone/>
             </a:pPr>
             <a:r>
@@ -23756,14 +23537,14 @@
       </p:sp>
       <p:sp>
         <p:nvSpPr>
-          <p:cNvPr id="80" name="서로 다른 도면의"/>
+          <p:cNvPr id="78" name="서로 다른 도면의불완전한 정보를 짝지어"/>
           <p:cNvSpPr txBox="1"/>
           <p:nvPr/>
         </p:nvSpPr>
         <p:spPr>
           <a:xfrm>
-            <a:off x="6604000" y="2303264"/>
-            <a:ext cx="959273" cy="177800"/>
+            <a:off x="6604000" y="2269331"/>
+            <a:ext cx="1344412" cy="423466"/>
           </a:xfrm>
           <a:prstGeom prst="rect">
             <a:avLst/>
@@ -23772,10 +23553,13 @@
           <a:ln/>
         </p:spPr>
         <p:txBody>
-          <a:bodyPr wrap="none" lIns="0" tIns="0" rIns="0" bIns="0" rtlCol="0" anchor="ctr"/>
-          <a:lstStyle/>
-          <a:p>
-            <a:pPr algn="l" indent="0" marL="0">
+          <a:bodyPr wrap="none" lIns="0" tIns="0" rIns="0" bIns="0" rtlCol="0" anchor="t"/>
+          <a:lstStyle/>
+          <a:p>
+            <a:pPr algn="l" indent="0" marL="0">
+              <a:lnSpc>
+                <a:spcPts val="1667"/>
+              </a:lnSpc>
               <a:buNone/>
             </a:pPr>
             <a:r>
@@ -23791,30 +23575,11 @@
             </a:r>
             <a:endParaRPr lang="en-US" sz="1150" dirty="0"/>
           </a:p>
-        </p:txBody>
-      </p:sp>
-      <p:sp>
-        <p:nvSpPr>
-          <p:cNvPr id="81" name="불완전한 정보를 짝지어"/>
-          <p:cNvSpPr txBox="1"/>
-          <p:nvPr/>
-        </p:nvSpPr>
-        <p:spPr>
-          <a:xfrm>
-            <a:off x="6604000" y="2514997"/>
-            <a:ext cx="1344412" cy="177800"/>
-          </a:xfrm>
-          <a:prstGeom prst="rect">
-            <a:avLst/>
-          </a:prstGeom>
-          <a:noFill/>
-          <a:ln/>
-        </p:spPr>
-        <p:txBody>
-          <a:bodyPr wrap="none" lIns="0" tIns="0" rIns="0" bIns="0" rtlCol="0" anchor="ctr"/>
-          <a:lstStyle/>
-          <a:p>
-            <a:pPr algn="l" indent="0" marL="0">
+          <a:p>
+            <a:pPr algn="l" indent="0" marL="0">
+              <a:lnSpc>
+                <a:spcPts val="1667"/>
+              </a:lnSpc>
               <a:buNone/>
             </a:pPr>
             <a:r>
@@ -23834,7 +23599,7 @@
       </p:sp>
       <p:sp>
         <p:nvSpPr>
-          <p:cNvPr id="82" name="하나의 3D 모델로 통합"/>
+          <p:cNvPr id="79" name="하나의 3D 모델로 통합"/>
           <p:cNvSpPr txBox="1"/>
           <p:nvPr/>
         </p:nvSpPr>
@@ -23873,7 +23638,7 @@
       </p:sp>
       <p:sp>
         <p:nvSpPr>
-          <p:cNvPr id="83" name="과제 2"/>
+          <p:cNvPr id="80" name="과제 2"/>
           <p:cNvSpPr txBox="1"/>
           <p:nvPr/>
         </p:nvSpPr>
@@ -23912,7 +23677,7 @@
       </p:sp>
       <p:sp>
         <p:nvSpPr>
-          <p:cNvPr id="84" name="기존 시설의 디지털 전환"/>
+          <p:cNvPr id="81" name="기존 시설의 디지털 전환"/>
           <p:cNvSpPr txBox="1"/>
           <p:nvPr/>
         </p:nvSpPr>
@@ -23951,14 +23716,14 @@
       </p:sp>
       <p:sp>
         <p:nvSpPr>
-          <p:cNvPr id="85" name="이미지 도면만 남은"/>
+          <p:cNvPr id="82" name="이미지 도면만 남은기존 시설이 많음"/>
           <p:cNvSpPr txBox="1"/>
           <p:nvPr/>
         </p:nvSpPr>
         <p:spPr>
           <a:xfrm>
-            <a:off x="3841750" y="3480197"/>
-            <a:ext cx="1059186" cy="165100"/>
+            <a:off x="3841750" y="3435747"/>
+            <a:ext cx="1059186" cy="419100"/>
           </a:xfrm>
           <a:prstGeom prst="rect">
             <a:avLst/>
@@ -23967,10 +23732,13 @@
           <a:ln/>
         </p:spPr>
         <p:txBody>
-          <a:bodyPr wrap="none" lIns="0" tIns="0" rIns="0" bIns="0" rtlCol="0" anchor="ctr"/>
-          <a:lstStyle/>
-          <a:p>
-            <a:pPr algn="l" indent="0" marL="0">
+          <a:bodyPr wrap="none" lIns="0" tIns="0" rIns="0" bIns="0" rtlCol="0" anchor="t"/>
+          <a:lstStyle/>
+          <a:p>
+            <a:pPr algn="l" indent="0" marL="0">
+              <a:lnSpc>
+                <a:spcPts val="1650"/>
+              </a:lnSpc>
               <a:buNone/>
             </a:pPr>
             <a:r>
@@ -23986,30 +23754,11 @@
             </a:r>
             <a:endParaRPr lang="en-US" sz="1100" dirty="0"/>
           </a:p>
-        </p:txBody>
-      </p:sp>
-      <p:sp>
-        <p:nvSpPr>
-          <p:cNvPr id="86" name="기존 시설이 많음"/>
-          <p:cNvSpPr txBox="1"/>
-          <p:nvPr/>
-        </p:nvSpPr>
-        <p:spPr>
-          <a:xfrm>
-            <a:off x="3841750" y="3689747"/>
-            <a:ext cx="934873" cy="165100"/>
-          </a:xfrm>
-          <a:prstGeom prst="rect">
-            <a:avLst/>
-          </a:prstGeom>
-          <a:noFill/>
-          <a:ln/>
-        </p:spPr>
-        <p:txBody>
-          <a:bodyPr wrap="none" lIns="0" tIns="0" rIns="0" bIns="0" rtlCol="0" anchor="ctr"/>
-          <a:lstStyle/>
-          <a:p>
-            <a:pPr algn="l" indent="0" marL="0">
+          <a:p>
+            <a:pPr algn="l" indent="0" marL="0">
+              <a:lnSpc>
+                <a:spcPts val="1650"/>
+              </a:lnSpc>
               <a:buNone/>
             </a:pPr>
             <a:r>
@@ -24029,14 +23778,14 @@
       </p:sp>
       <p:sp>
         <p:nvSpPr>
-          <p:cNvPr id="87" name="CAD 정보 없이"/>
+          <p:cNvPr id="83" name="CAD 정보 없이이미지 도면에서 BIM 생성"/>
           <p:cNvSpPr txBox="1"/>
           <p:nvPr/>
         </p:nvSpPr>
         <p:spPr>
           <a:xfrm>
-            <a:off x="6604000" y="3471664"/>
-            <a:ext cx="888107" cy="177800"/>
+            <a:off x="6604000" y="3437731"/>
+            <a:ext cx="1506377" cy="423466"/>
           </a:xfrm>
           <a:prstGeom prst="rect">
             <a:avLst/>
@@ -24045,10 +23794,13 @@
           <a:ln/>
         </p:spPr>
         <p:txBody>
-          <a:bodyPr wrap="none" lIns="0" tIns="0" rIns="0" bIns="0" rtlCol="0" anchor="ctr"/>
-          <a:lstStyle/>
-          <a:p>
-            <a:pPr algn="l" indent="0" marL="0">
+          <a:bodyPr wrap="none" lIns="0" tIns="0" rIns="0" bIns="0" rtlCol="0" anchor="t"/>
+          <a:lstStyle/>
+          <a:p>
+            <a:pPr algn="l" indent="0" marL="0">
+              <a:lnSpc>
+                <a:spcPts val="1667"/>
+              </a:lnSpc>
               <a:buNone/>
             </a:pPr>
             <a:r>
@@ -24064,30 +23816,11 @@
             </a:r>
             <a:endParaRPr lang="en-US" sz="1150" dirty="0"/>
           </a:p>
-        </p:txBody>
-      </p:sp>
-      <p:sp>
-        <p:nvSpPr>
-          <p:cNvPr id="88" name="이미지 도면에서 BIM 생성"/>
-          <p:cNvSpPr txBox="1"/>
-          <p:nvPr/>
-        </p:nvSpPr>
-        <p:spPr>
-          <a:xfrm>
-            <a:off x="6604000" y="3683397"/>
-            <a:ext cx="1506377" cy="177800"/>
-          </a:xfrm>
-          <a:prstGeom prst="rect">
-            <a:avLst/>
-          </a:prstGeom>
-          <a:noFill/>
-          <a:ln/>
-        </p:spPr>
-        <p:txBody>
-          <a:bodyPr wrap="none" lIns="0" tIns="0" rIns="0" bIns="0" rtlCol="0" anchor="ctr"/>
-          <a:lstStyle/>
-          <a:p>
-            <a:pPr algn="l" indent="0" marL="0">
+          <a:p>
+            <a:pPr algn="l" indent="0" marL="0">
+              <a:lnSpc>
+                <a:spcPts val="1667"/>
+              </a:lnSpc>
               <a:buNone/>
             </a:pPr>
             <a:r>
@@ -24107,7 +23840,7 @@
       </p:sp>
       <p:sp>
         <p:nvSpPr>
-          <p:cNvPr id="89" name="디지털 전환 기간 단축"/>
+          <p:cNvPr id="84" name="디지털 전환 기간 단축"/>
           <p:cNvSpPr txBox="1"/>
           <p:nvPr/>
         </p:nvSpPr>
@@ -24146,7 +23879,7 @@
       </p:sp>
       <p:sp>
         <p:nvSpPr>
-          <p:cNvPr id="90" name="과제 3"/>
+          <p:cNvPr id="85" name="과제 3"/>
           <p:cNvSpPr txBox="1"/>
           <p:nvPr/>
         </p:nvSpPr>
@@ -24185,7 +23918,7 @@
       </p:sp>
       <p:sp>
         <p:nvSpPr>
-          <p:cNvPr id="91" name="5D(물량·원가) 관리"/>
+          <p:cNvPr id="86" name="5D(물량·원가) 관리"/>
           <p:cNvSpPr txBox="1"/>
           <p:nvPr/>
         </p:nvSpPr>
@@ -24224,14 +23957,14 @@
       </p:sp>
       <p:sp>
         <p:nvSpPr>
-          <p:cNvPr id="92" name="BIM 데이터가 정확해야"/>
+          <p:cNvPr id="87" name="BIM 데이터가 정확해야물량·원가 관리가 의미 있음"/>
           <p:cNvSpPr txBox="1"/>
           <p:nvPr/>
         </p:nvSpPr>
         <p:spPr>
           <a:xfrm>
-            <a:off x="3841750" y="4648597"/>
-            <a:ext cx="1305498" cy="165100"/>
+            <a:off x="3841750" y="4604147"/>
+            <a:ext cx="1499856" cy="419100"/>
           </a:xfrm>
           <a:prstGeom prst="rect">
             <a:avLst/>
@@ -24240,10 +23973,13 @@
           <a:ln/>
         </p:spPr>
         <p:txBody>
-          <a:bodyPr wrap="none" lIns="0" tIns="0" rIns="0" bIns="0" rtlCol="0" anchor="ctr"/>
-          <a:lstStyle/>
-          <a:p>
-            <a:pPr algn="l" indent="0" marL="0">
+          <a:bodyPr wrap="none" lIns="0" tIns="0" rIns="0" bIns="0" rtlCol="0" anchor="t"/>
+          <a:lstStyle/>
+          <a:p>
+            <a:pPr algn="l" indent="0" marL="0">
+              <a:lnSpc>
+                <a:spcPts val="1650"/>
+              </a:lnSpc>
               <a:buNone/>
             </a:pPr>
             <a:r>
@@ -24259,30 +23995,11 @@
             </a:r>
             <a:endParaRPr lang="en-US" sz="1100" dirty="0"/>
           </a:p>
-        </p:txBody>
-      </p:sp>
-      <p:sp>
-        <p:nvSpPr>
-          <p:cNvPr id="93" name="물량·원가 관리가 의미 있음"/>
-          <p:cNvSpPr txBox="1"/>
-          <p:nvPr/>
-        </p:nvSpPr>
-        <p:spPr>
-          <a:xfrm>
-            <a:off x="3841750" y="4858147"/>
-            <a:ext cx="1499856" cy="165100"/>
-          </a:xfrm>
-          <a:prstGeom prst="rect">
-            <a:avLst/>
-          </a:prstGeom>
-          <a:noFill/>
-          <a:ln/>
-        </p:spPr>
-        <p:txBody>
-          <a:bodyPr wrap="none" lIns="0" tIns="0" rIns="0" bIns="0" rtlCol="0" anchor="ctr"/>
-          <a:lstStyle/>
-          <a:p>
-            <a:pPr algn="l" indent="0" marL="0">
+          <a:p>
+            <a:pPr algn="l" indent="0" marL="0">
+              <a:lnSpc>
+                <a:spcPts val="1650"/>
+              </a:lnSpc>
               <a:buNone/>
             </a:pPr>
             <a:r>
@@ -24302,14 +24019,14 @@
       </p:sp>
       <p:sp>
         <p:nvSpPr>
-          <p:cNvPr id="94" name="축척 보정·생성 완성도"/>
+          <p:cNvPr id="88" name="축척 보정·생성 완성도검증 경험"/>
           <p:cNvSpPr txBox="1"/>
           <p:nvPr/>
         </p:nvSpPr>
         <p:spPr>
           <a:xfrm>
-            <a:off x="6604000" y="4640064"/>
-            <a:ext cx="1254280" cy="177800"/>
+            <a:off x="6604000" y="4606131"/>
+            <a:ext cx="1254280" cy="423466"/>
           </a:xfrm>
           <a:prstGeom prst="rect">
             <a:avLst/>
@@ -24318,10 +24035,13 @@
           <a:ln/>
         </p:spPr>
         <p:txBody>
-          <a:bodyPr wrap="none" lIns="0" tIns="0" rIns="0" bIns="0" rtlCol="0" anchor="ctr"/>
-          <a:lstStyle/>
-          <a:p>
-            <a:pPr algn="l" indent="0" marL="0">
+          <a:bodyPr wrap="none" lIns="0" tIns="0" rIns="0" bIns="0" rtlCol="0" anchor="t"/>
+          <a:lstStyle/>
+          <a:p>
+            <a:pPr algn="l" indent="0" marL="0">
+              <a:lnSpc>
+                <a:spcPts val="1667"/>
+              </a:lnSpc>
               <a:buNone/>
             </a:pPr>
             <a:r>
@@ -24337,30 +24057,11 @@
             </a:r>
             <a:endParaRPr lang="en-US" sz="1150" dirty="0"/>
           </a:p>
-        </p:txBody>
-      </p:sp>
-      <p:sp>
-        <p:nvSpPr>
-          <p:cNvPr id="95" name="검증 경험"/>
-          <p:cNvSpPr txBox="1"/>
-          <p:nvPr/>
-        </p:nvSpPr>
-        <p:spPr>
-          <a:xfrm>
-            <a:off x="6604000" y="4851797"/>
-            <a:ext cx="563860" cy="177800"/>
-          </a:xfrm>
-          <a:prstGeom prst="rect">
-            <a:avLst/>
-          </a:prstGeom>
-          <a:noFill/>
-          <a:ln/>
-        </p:spPr>
-        <p:txBody>
-          <a:bodyPr wrap="none" lIns="0" tIns="0" rIns="0" bIns="0" rtlCol="0" anchor="ctr"/>
-          <a:lstStyle/>
-          <a:p>
-            <a:pPr algn="l" indent="0" marL="0">
+          <a:p>
+            <a:pPr algn="l" indent="0" marL="0">
+              <a:lnSpc>
+                <a:spcPts val="1667"/>
+              </a:lnSpc>
               <a:buNone/>
             </a:pPr>
             <a:r>
@@ -24380,14 +24081,14 @@
       </p:sp>
       <p:sp>
         <p:nvSpPr>
-          <p:cNvPr id="96" name="모델 데이터 품질 검증에"/>
+          <p:cNvPr id="89" name="모델 데이터 품질 검증에바로 활용"/>
           <p:cNvSpPr txBox="1"/>
           <p:nvPr/>
         </p:nvSpPr>
         <p:spPr>
           <a:xfrm>
-            <a:off x="8978900" y="4620716"/>
-            <a:ext cx="1538980" cy="196850"/>
+            <a:off x="8978900" y="4586486"/>
+            <a:ext cx="1538980" cy="462161"/>
           </a:xfrm>
           <a:prstGeom prst="rect">
             <a:avLst/>
@@ -24396,10 +24097,13 @@
           <a:ln/>
         </p:spPr>
         <p:txBody>
-          <a:bodyPr wrap="none" lIns="0" tIns="0" rIns="0" bIns="0" rtlCol="0" anchor="ctr"/>
-          <a:lstStyle/>
-          <a:p>
-            <a:pPr algn="l" indent="0" marL="0">
+          <a:bodyPr wrap="none" lIns="0" tIns="0" rIns="0" bIns="0" rtlCol="0" anchor="t"/>
+          <a:lstStyle/>
+          <a:p>
+            <a:pPr algn="l" indent="0" marL="0">
+              <a:lnSpc>
+                <a:spcPts val="1820"/>
+              </a:lnSpc>
               <a:buNone/>
             </a:pPr>
             <a:r>
@@ -24415,30 +24119,11 @@
             </a:r>
             <a:endParaRPr lang="en-US" sz="1300" dirty="0"/>
           </a:p>
-        </p:txBody>
-      </p:sp>
-      <p:sp>
-        <p:nvSpPr>
-          <p:cNvPr id="97" name="바로 활용"/>
-          <p:cNvSpPr txBox="1"/>
-          <p:nvPr/>
-        </p:nvSpPr>
-        <p:spPr>
-          <a:xfrm>
-            <a:off x="8978900" y="4851797"/>
-            <a:ext cx="625475" cy="196850"/>
-          </a:xfrm>
-          <a:prstGeom prst="rect">
-            <a:avLst/>
-          </a:prstGeom>
-          <a:noFill/>
-          <a:ln/>
-        </p:spPr>
-        <p:txBody>
-          <a:bodyPr wrap="none" lIns="0" tIns="0" rIns="0" bIns="0" rtlCol="0" anchor="ctr"/>
-          <a:lstStyle/>
-          <a:p>
-            <a:pPr algn="l" indent="0" marL="0">
+          <a:p>
+            <a:pPr algn="l" indent="0" marL="0">
+              <a:lnSpc>
+                <a:spcPts val="1820"/>
+              </a:lnSpc>
               <a:buNone/>
             </a:pPr>
             <a:r>
@@ -24458,7 +24143,7 @@
       </p:sp>
       <p:sp>
         <p:nvSpPr>
-          <p:cNvPr id="98" name="KEY MESSAGE"/>
+          <p:cNvPr id="90" name="KEY MESSAGE"/>
           <p:cNvSpPr txBox="1"/>
           <p:nvPr/>
         </p:nvSpPr>
@@ -24497,14 +24182,14 @@
       </p:sp>
       <p:sp>
         <p:nvSpPr>
-          <p:cNvPr id="99" name="도면 속 불완전한 정보를 정확한 3D 데이터로 잇는 경험으로,"/>
+          <p:cNvPr id="91" name="도면 속 불완전한 정보를 정확한 3D 데이터로 잇는 경험으로,SK하이닉스"/>
           <p:cNvSpPr txBox="1"/>
           <p:nvPr/>
         </p:nvSpPr>
         <p:spPr>
           <a:xfrm>
-            <a:off x="1854994" y="5755680"/>
-            <a:ext cx="4027136" cy="209550"/>
+            <a:off x="1854994" y="5725220"/>
+            <a:ext cx="4027136" cy="480020"/>
           </a:xfrm>
           <a:prstGeom prst="rect">
             <a:avLst/>
@@ -24513,10 +24198,13 @@
           <a:ln/>
         </p:spPr>
         <p:txBody>
-          <a:bodyPr wrap="none" lIns="0" tIns="0" rIns="0" bIns="0" rtlCol="0" anchor="ctr"/>
-          <a:lstStyle/>
-          <a:p>
-            <a:pPr algn="l" indent="0" marL="0">
+          <a:bodyPr wrap="none" lIns="0" tIns="0" rIns="0" bIns="0" rtlCol="0" anchor="t"/>
+          <a:lstStyle/>
+          <a:p>
+            <a:pPr algn="l" indent="0" marL="0">
+              <a:lnSpc>
+                <a:spcPts val="1890"/>
+              </a:lnSpc>
               <a:buNone/>
             </a:pPr>
             <a:r>
@@ -24531,6 +24219,9 @@
               <a:t>도면 속 불완전한 정보를 </a:t>
             </a:r>
             <a:pPr algn="l" indent="0" marL="0">
+              <a:lnSpc>
+                <a:spcPts val="1890"/>
+              </a:lnSpc>
               <a:buNone/>
             </a:pPr>
             <a:r>
@@ -24545,6 +24236,9 @@
               <a:t>정확한 3D 데이터</a:t>
             </a:r>
             <a:pPr algn="l" indent="0" marL="0">
+              <a:lnSpc>
+                <a:spcPts val="1890"/>
+              </a:lnSpc>
               <a:buNone/>
             </a:pPr>
             <a:r>
@@ -24560,30 +24254,11 @@
             </a:r>
             <a:endParaRPr lang="en-US" sz="1350" dirty="0"/>
           </a:p>
-        </p:txBody>
-      </p:sp>
-      <p:sp>
-        <p:nvSpPr>
-          <p:cNvPr id="100" name="SK하이닉스 Virtual FAB의 데이터 품질을 높이겠습니다."/>
-          <p:cNvSpPr txBox="1"/>
-          <p:nvPr/>
-        </p:nvSpPr>
-        <p:spPr>
-          <a:xfrm>
-            <a:off x="1854994" y="5995690"/>
-            <a:ext cx="3852025" cy="209550"/>
-          </a:xfrm>
-          <a:prstGeom prst="rect">
-            <a:avLst/>
-          </a:prstGeom>
-          <a:noFill/>
-          <a:ln/>
-        </p:spPr>
-        <p:txBody>
-          <a:bodyPr wrap="none" lIns="0" tIns="0" rIns="0" bIns="0" rtlCol="0" anchor="ctr"/>
-          <a:lstStyle/>
-          <a:p>
-            <a:pPr algn="l" indent="0" marL="0">
+          <a:p>
+            <a:pPr algn="l" indent="0" marL="0">
+              <a:lnSpc>
+                <a:spcPts val="1890"/>
+              </a:lnSpc>
               <a:buNone/>
             </a:pPr>
             <a:r>
@@ -24603,7 +24278,7 @@
       </p:sp>
       <p:sp>
         <p:nvSpPr>
-          <p:cNvPr id="101" name="감사합니다"/>
+          <p:cNvPr id="92" name="감사합니다"/>
           <p:cNvSpPr txBox="1"/>
           <p:nvPr/>
         </p:nvSpPr>
@@ -24642,7 +24317,7 @@
       </p:sp>
       <p:sp>
         <p:nvSpPr>
-          <p:cNvPr id="102" name="· Q&amp;A"/>
+          <p:cNvPr id="93" name="· Q&amp;A"/>
           <p:cNvSpPr txBox="1"/>
           <p:nvPr/>
         </p:nvSpPr>
@@ -24681,7 +24356,7 @@
       </p:sp>
       <p:sp>
         <p:nvSpPr>
-          <p:cNvPr id="103" name="Automation in Construction · Vol. 187 · "/>
+          <p:cNvPr id="94" name="Automation in Construction · Vol. 187 · "/>
           <p:cNvSpPr txBox="1"/>
           <p:nvPr/>
         </p:nvSpPr>
@@ -24734,7 +24409,7 @@
       </p:sp>
       <p:sp>
         <p:nvSpPr>
-          <p:cNvPr id="104" name="석사 연구 발표  ·  평면도와 입면도 객체 인식 및 정보 통합을 통한 "/>
+          <p:cNvPr id="95" name="석사 연구 발표  ·  평면도와 입면도 객체 인식 및 정보 통합을 통한 "/>
           <p:cNvSpPr txBox="1"/>
           <p:nvPr/>
         </p:nvSpPr>
@@ -24773,7 +24448,7 @@
       </p:sp>
       <p:sp>
         <p:nvSpPr>
-          <p:cNvPr id="105" name="05 / 05"/>
+          <p:cNvPr id="96" name="05 / 05"/>
           <p:cNvSpPr txBox="1"/>
           <p:nvPr/>
         </p:nvSpPr>

</xml_diff>